<commit_message>
R2 audit: journal O_APPEND (PERF-1), strict mypy, uvicorn limits, CIS compose, EGRUL reorganization/termination (ст.188), card a11y, mutation runner, load harness + CI smoke, test scenarios, load report, R2 audit doc, deck rebuilt (714 tests)
</commit_message>
<xml_diff>
--- a/submission/slides/Mandat_VTB.pptx
+++ b/submission/slides/Mandat_VTB.pptx
@@ -133,7 +133,7 @@
   <p:extLst>
     <p:ext uri="{521415D9-36F7-43E2-AB2F-B90AF26B5E84}">
       <p14:sectionLst xmlns:p14="http://schemas.microsoft.com/office/powerpoint/2010/main">
-        <p14:section name="Питч · 5 минут" id="{90137de3-f457-e778-371c-174fdfb7bd0b}">
+        <p14:section name="Питч · 5 минут" id="{6a6abdea-15ea-2a55-5854-1517b6515a59}">
           <p14:sldIdLst>
             <p14:sldId id="256"/>
             <p14:sldId id="257"/>
@@ -151,7 +151,7 @@
             <p14:sldId id="269"/>
           </p14:sldIdLst>
         </p14:section>
-        <p14:section name="Приложение для вопросов жюри" id="{5f7e4d2d-ec77-754e-ed88-9c60a8a5150a}">
+        <p14:section name="Приложение для вопросов жюри" id="{e1021896-3eef-b70f-86a9-e68aef450b88}">
           <p14:sldIdLst>
             <p14:sldId id="270"/>
             <p14:sldId id="271"/>
@@ -6093,7 +6093,7 @@
                   <a:schemeClr val="accent4"/>
                 </a:solidFill>
               </a:rPr>
-              <a:t>Источники: vtb.ru — «Комплект МЧД и КЭП» в «ВТБ Бизнес», 10.2026; репозиторий «Мандата» v0.3.0: 585 автотестов, evidence.json от 13.10.2026</a:t>
+              <a:t>Источники: vtb.ru — «Комплект МЧД и КЭП» в «ВТБ Бизнес», 10.2026; репозиторий «Мандата» v0.3.0: 714 автотестов, evidence.json от 14.10.2026</a:t>
             </a:r>
             <a:endParaRPr lang="en-US" sz="1000" dirty="0"/>
           </a:p>
@@ -6956,7 +6956,7 @@
                   <a:schemeClr val="bg1"/>
                 </a:solidFill>
               </a:rPr>
-              <a:t>585 автотестов проходят, каждое число воспроизводится командой</a:t>
+              <a:t>714 автотестов проходят, каждое число воспроизводится командой</a:t>
             </a:r>
             <a:endParaRPr lang="en-US" sz="1500" dirty="0"/>
           </a:p>
@@ -23545,7 +23545,7 @@
                           <a:ea typeface="Calibri" pitchFamily="34" charset="-122"/>
                           <a:cs typeface="Calibri" pitchFamily="34" charset="-120"/>
                         </a:rPr>
-                        <a:t>585 автотестов проходят (v0.3.0, evidence.json), независимая проверка на Cedar, реестр утверждений: каждое число воспроизводится командой</a:t>
+                        <a:t>714 автотестов проходят (v0.3.0, evidence.json), независимая проверка на Cedar, реестр утверждений: каждое число воспроизводится командой</a:t>
                       </a:r>
                       <a:endParaRPr lang="en-US" sz="1300" dirty="0">
                         <a:latin typeface="Calibri" charset="0"/>
@@ -31541,7 +31541,7 @@
                   <a:schemeClr val="accent4"/>
                 </a:solidFill>
               </a:rPr>
-              <a:t>Воспроизводится: mandat eval --per-defect 6; python -m pytest tests/test_properties.py tests/test_cedar.py; python scripts/bench.py → evidence.json (13.10.2026, v0.3.0)</a:t>
+              <a:t>Воспроизводится: mandat eval --per-defect 6; python -m pytest tests/test_properties.py tests/test_cedar.py; python scripts/bench.py → evidence.json (14.10.2026, v0.3.0)</a:t>
             </a:r>
             <a:endParaRPr lang="en-US" sz="1000" dirty="0"/>
           </a:p>

</xml_diff>

<commit_message>
R2.1: journal segments (PERF-2), generic 422/500/503 with request_id (API-3), hash-pinned build backend (SC-1), evidence test-count fix (714 vs 715), deck rebuilt (731 tests)
</commit_message>
<xml_diff>
--- a/submission/slides/Mandat_VTB.pptx
+++ b/submission/slides/Mandat_VTB.pptx
@@ -133,7 +133,7 @@
   <p:extLst>
     <p:ext uri="{521415D9-36F7-43E2-AB2F-B90AF26B5E84}">
       <p14:sectionLst xmlns:p14="http://schemas.microsoft.com/office/powerpoint/2010/main">
-        <p14:section name="Питч · 5 минут" id="{6a6abdea-15ea-2a55-5854-1517b6515a59}">
+        <p14:section name="Питч · 5 минут" id="{33e74e2e-95ad-77ee-71cf-24ab4cc09bce}">
           <p14:sldIdLst>
             <p14:sldId id="256"/>
             <p14:sldId id="257"/>
@@ -151,7 +151,7 @@
             <p14:sldId id="269"/>
           </p14:sldIdLst>
         </p14:section>
-        <p14:section name="Приложение для вопросов жюри" id="{e1021896-3eef-b70f-86a9-e68aef450b88}">
+        <p14:section name="Приложение для вопросов жюри" id="{7739d56b-cf73-72d4-1420-6eefa2c863fc}">
           <p14:sldIdLst>
             <p14:sldId id="270"/>
             <p14:sldId id="271"/>
@@ -6093,7 +6093,7 @@
                   <a:schemeClr val="accent4"/>
                 </a:solidFill>
               </a:rPr>
-              <a:t>Источники: vtb.ru — «Комплект МЧД и КЭП» в «ВТБ Бизнес», 10.2026; репозиторий «Мандата» v0.3.0: 714 автотестов, evidence.json от 14.10.2026</a:t>
+              <a:t>Источники: vtb.ru — «Комплект МЧД и КЭП» в «ВТБ Бизнес», 10.2026; репозиторий «Мандата» v0.3.0: 731 автотест, evidence.json от 14.10.2026</a:t>
             </a:r>
             <a:endParaRPr lang="en-US" sz="1000" dirty="0"/>
           </a:p>
@@ -6956,7 +6956,7 @@
                   <a:schemeClr val="bg1"/>
                 </a:solidFill>
               </a:rPr>
-              <a:t>714 автотестов проходят, каждое число воспроизводится командой</a:t>
+              <a:t>731 автотест проходят, каждое число воспроизводится командой</a:t>
             </a:r>
             <a:endParaRPr lang="en-US" sz="1500" dirty="0"/>
           </a:p>
@@ -23545,7 +23545,7 @@
                           <a:ea typeface="Calibri" pitchFamily="34" charset="-122"/>
                           <a:cs typeface="Calibri" pitchFamily="34" charset="-120"/>
                         </a:rPr>
-                        <a:t>714 автотестов проходят (v0.3.0, evidence.json), независимая проверка на Cedar, реестр утверждений: каждое число воспроизводится командой</a:t>
+                        <a:t>731 автотест проходят (v0.3.0, evidence.json), независимая проверка на Cedar, реестр утверждений: каждое число воспроизводится командой</a:t>
                       </a:r>
                       <a:endParaRPr lang="en-US" sz="1300" dirty="0">
                         <a:latin typeface="Calibri" charset="0"/>

</xml_diff>

<commit_message>
R3: external journal anchor (file/webhook/RFC 3161/Rekor), hash-pinned pip and CI tools, Redis load: TCP_NODELAY with --workers, journal catch-up across processes, load harness stderr fix; docs, evidence (762 tests), deck
</commit_message>
<xml_diff>
--- a/submission/slides/Mandat_VTB.pptx
+++ b/submission/slides/Mandat_VTB.pptx
@@ -133,7 +133,7 @@
   <p:extLst>
     <p:ext uri="{521415D9-36F7-43E2-AB2F-B90AF26B5E84}">
       <p14:sectionLst xmlns:p14="http://schemas.microsoft.com/office/powerpoint/2010/main">
-        <p14:section name="Питч · 5 минут" id="{33e74e2e-95ad-77ee-71cf-24ab4cc09bce}">
+        <p14:section name="Питч · 5 минут" id="{4e561cc6-e9d1-2381-4ccb-6134dcd699ec}">
           <p14:sldIdLst>
             <p14:sldId id="256"/>
             <p14:sldId id="257"/>
@@ -151,7 +151,7 @@
             <p14:sldId id="269"/>
           </p14:sldIdLst>
         </p14:section>
-        <p14:section name="Приложение для вопросов жюри" id="{7739d56b-cf73-72d4-1420-6eefa2c863fc}">
+        <p14:section name="Приложение для вопросов жюри" id="{fedce28e-a3a2-10e0-24c6-e5ad0d54a989}">
           <p14:sldIdLst>
             <p14:sldId id="270"/>
             <p14:sldId id="271"/>
@@ -6093,7 +6093,7 @@
                   <a:schemeClr val="accent4"/>
                 </a:solidFill>
               </a:rPr>
-              <a:t>Источники: vtb.ru — «Комплект МЧД и КЭП» в «ВТБ Бизнес», 10.2026; репозиторий «Мандата» v0.3.0: 731 автотест, evidence.json от 14.10.2026</a:t>
+              <a:t>Источники: vtb.ru — «Комплект МЧД и КЭП» в «ВТБ Бизнес», 10.2026; репозиторий «Мандата» v0.3.0: 762 автотеста, evidence.json от 14.10.2026</a:t>
             </a:r>
             <a:endParaRPr lang="en-US" sz="1000" dirty="0"/>
           </a:p>
@@ -6956,7 +6956,7 @@
                   <a:schemeClr val="bg1"/>
                 </a:solidFill>
               </a:rPr>
-              <a:t>731 автотест проходят, каждое число воспроизводится командой</a:t>
+              <a:t>762 автотеста проходят, каждое число воспроизводится командой</a:t>
             </a:r>
             <a:endParaRPr lang="en-US" sz="1500" dirty="0"/>
           </a:p>
@@ -23545,7 +23545,7 @@
                           <a:ea typeface="Calibri" pitchFamily="34" charset="-122"/>
                           <a:cs typeface="Calibri" pitchFamily="34" charset="-120"/>
                         </a:rPr>
-                        <a:t>731 автотест проходят (v0.3.0, evidence.json), независимая проверка на Cedar, реестр утверждений: каждое число воспроизводится командой</a:t>
+                        <a:t>762 автотеста проходят (v0.3.0, evidence.json), независимая проверка на Cedar, реестр утверждений: каждое число воспроизводится командой</a:t>
                       </a:r>
                       <a:endParaRPr lang="en-US" sz="1300" dirty="0">
                         <a:latin typeface="Calibri" charset="0"/>

</xml_diff>

<commit_message>
R4: Rekor inclusion proof + signed checkpoint, TSA chain to configured root with timeStamping EKU and signer lookup by sid, segment manifest (O(1) per append, 4-worker soak flat), evidence rebuilt (782 tests), docs, deck
</commit_message>
<xml_diff>
--- a/submission/slides/Mandat_VTB.pptx
+++ b/submission/slides/Mandat_VTB.pptx
@@ -133,7 +133,7 @@
   <p:extLst>
     <p:ext uri="{521415D9-36F7-43E2-AB2F-B90AF26B5E84}">
       <p14:sectionLst xmlns:p14="http://schemas.microsoft.com/office/powerpoint/2010/main">
-        <p14:section name="Питч · 5 минут" id="{4e561cc6-e9d1-2381-4ccb-6134dcd699ec}">
+        <p14:section name="Питч · 5 минут" id="{b1a114d8-1274-edc8-8fc9-9680774e20b8}">
           <p14:sldIdLst>
             <p14:sldId id="256"/>
             <p14:sldId id="257"/>
@@ -151,7 +151,7 @@
             <p14:sldId id="269"/>
           </p14:sldIdLst>
         </p14:section>
-        <p14:section name="Приложение для вопросов жюри" id="{fedce28e-a3a2-10e0-24c6-e5ad0d54a989}">
+        <p14:section name="Приложение для вопросов жюри" id="{9ab15b76-e2ef-09c5-f90b-f4d6c067346d}">
           <p14:sldIdLst>
             <p14:sldId id="270"/>
             <p14:sldId id="271"/>
@@ -6093,7 +6093,7 @@
                   <a:schemeClr val="accent4"/>
                 </a:solidFill>
               </a:rPr>
-              <a:t>Источники: vtb.ru — «Комплект МЧД и КЭП» в «ВТБ Бизнес», 10.2026; репозиторий «Мандата» v0.3.0: 762 автотеста, evidence.json от 14.10.2026</a:t>
+              <a:t>Источники: vtb.ru — «Комплект МЧД и КЭП» в «ВТБ Бизнес», 10.2026; репозиторий «Мандата» v0.3.0: 782 автотеста, evidence.json от 14.10.2026</a:t>
             </a:r>
             <a:endParaRPr lang="en-US" sz="1000" dirty="0"/>
           </a:p>
@@ -6956,7 +6956,7 @@
                   <a:schemeClr val="bg1"/>
                 </a:solidFill>
               </a:rPr>
-              <a:t>762 автотеста проходят, каждое число воспроизводится командой</a:t>
+              <a:t>782 автотеста проходят, каждое число воспроизводится командой</a:t>
             </a:r>
             <a:endParaRPr lang="en-US" sz="1500" dirty="0"/>
           </a:p>
@@ -23545,7 +23545,7 @@
                           <a:ea typeface="Calibri" pitchFamily="34" charset="-122"/>
                           <a:cs typeface="Calibri" pitchFamily="34" charset="-120"/>
                         </a:rPr>
-                        <a:t>762 автотеста проходят (v0.3.0, evidence.json), независимая проверка на Cedar, реестр утверждений: каждое число воспроизводится командой</a:t>
+                        <a:t>782 автотеста проходят (v0.3.0, evidence.json), независимая проверка на Cedar, реестр утверждений: каждое число воспроизводится командой</a:t>
                       </a:r>
                       <a:endParaRPr lang="en-US" sz="1300" dirty="0">
                         <a:latin typeface="Calibri" charset="0"/>

</xml_diff>

<commit_message>
anchor: Rekor v2 (rekor-tiles), SET and consistency proofs, TSA OCSP/CRL revocation, webhook read-back
</commit_message>
<xml_diff>
--- a/submission/slides/Mandat_VTB.pptx
+++ b/submission/slides/Mandat_VTB.pptx
@@ -133,7 +133,7 @@
   <p:extLst>
     <p:ext uri="{521415D9-36F7-43E2-AB2F-B90AF26B5E84}">
       <p14:sectionLst xmlns:p14="http://schemas.microsoft.com/office/powerpoint/2010/main">
-        <p14:section name="Питч · 5 минут" id="{b1a114d8-1274-edc8-8fc9-9680774e20b8}">
+        <p14:section name="Питч · 5 минут" id="{9770c435-96f5-4b2f-3590-68d222b0a4dc}">
           <p14:sldIdLst>
             <p14:sldId id="256"/>
             <p14:sldId id="257"/>
@@ -151,7 +151,7 @@
             <p14:sldId id="269"/>
           </p14:sldIdLst>
         </p14:section>
-        <p14:section name="Приложение для вопросов жюри" id="{9ab15b76-e2ef-09c5-f90b-f4d6c067346d}">
+        <p14:section name="Приложение для вопросов жюри" id="{f2cec953-0b8c-b7f2-584f-625c45fc31be}">
           <p14:sldIdLst>
             <p14:sldId id="270"/>
             <p14:sldId id="271"/>
@@ -6093,7 +6093,7 @@
                   <a:schemeClr val="accent4"/>
                 </a:solidFill>
               </a:rPr>
-              <a:t>Источники: vtb.ru — «Комплект МЧД и КЭП» в «ВТБ Бизнес», 10.2026; репозиторий «Мандата» v0.3.0: 782 автотеста, evidence.json от 14.10.2026</a:t>
+              <a:t>Источники: vtb.ru — «Комплект МЧД и КЭП» в «ВТБ Бизнес», 10.2026; репозиторий «Мандата» v0.3.0: 843 автотеста, evidence.json от 14.10.2026</a:t>
             </a:r>
             <a:endParaRPr lang="en-US" sz="1000" dirty="0"/>
           </a:p>
@@ -6956,7 +6956,7 @@
                   <a:schemeClr val="bg1"/>
                 </a:solidFill>
               </a:rPr>
-              <a:t>782 автотеста проходят, каждое число воспроизводится командой</a:t>
+              <a:t>843 автотеста проходят, каждое число воспроизводится командой</a:t>
             </a:r>
             <a:endParaRPr lang="en-US" sz="1500" dirty="0"/>
           </a:p>
@@ -23545,7 +23545,7 @@
                           <a:ea typeface="Calibri" pitchFamily="34" charset="-122"/>
                           <a:cs typeface="Calibri" pitchFamily="34" charset="-120"/>
                         </a:rPr>
-                        <a:t>782 автотеста проходят (v0.3.0, evidence.json), независимая проверка на Cedar, реестр утверждений: каждое число воспроизводится командой</a:t>
+                        <a:t>843 автотеста проходят (v0.3.0, evidence.json), независимая проверка на Cedar, реестр утверждений: каждое число воспроизводится командой</a:t>
                       </a:r>
                       <a:endParaRPr lang="en-US" sz="1300" dirty="0">
                         <a:latin typeface="Calibri" charset="0"/>

</xml_diff>

<commit_message>
anchor: witness cosignatures (C2SP tlog-cosignature) and Sigstore TrustedRoot/SigningConfig via TUF
</commit_message>
<xml_diff>
--- a/submission/slides/Mandat_VTB.pptx
+++ b/submission/slides/Mandat_VTB.pptx
@@ -133,7 +133,7 @@
   <p:extLst>
     <p:ext uri="{521415D9-36F7-43E2-AB2F-B90AF26B5E84}">
       <p14:sectionLst xmlns:p14="http://schemas.microsoft.com/office/powerpoint/2010/main">
-        <p14:section name="Питч · 5 минут" id="{9770c435-96f5-4b2f-3590-68d222b0a4dc}">
+        <p14:section name="Питч · 5 минут" id="{fcfb8e35-0ca8-951b-6f4b-f5d068a1c836}">
           <p14:sldIdLst>
             <p14:sldId id="256"/>
             <p14:sldId id="257"/>
@@ -151,7 +151,7 @@
             <p14:sldId id="269"/>
           </p14:sldIdLst>
         </p14:section>
-        <p14:section name="Приложение для вопросов жюри" id="{f2cec953-0b8c-b7f2-584f-625c45fc31be}">
+        <p14:section name="Приложение для вопросов жюри" id="{e5022ebd-4817-3d3c-2e1b-ec8adceee6ee}">
           <p14:sldIdLst>
             <p14:sldId id="270"/>
             <p14:sldId id="271"/>
@@ -6093,7 +6093,7 @@
                   <a:schemeClr val="accent4"/>
                 </a:solidFill>
               </a:rPr>
-              <a:t>Источники: vtb.ru — «Комплект МЧД и КЭП» в «ВТБ Бизнес», 10.2026; репозиторий «Мандата» v0.3.0: 843 автотеста, evidence.json от 14.10.2026</a:t>
+              <a:t>Источники: vtb.ru — «Комплект МЧД и КЭП» в «ВТБ Бизнес», 10.2026; репозиторий «Мандата» v0.3.0: 858 автотестов, evidence.json от 14.10.2026</a:t>
             </a:r>
             <a:endParaRPr lang="en-US" sz="1000" dirty="0"/>
           </a:p>
@@ -6956,7 +6956,7 @@
                   <a:schemeClr val="bg1"/>
                 </a:solidFill>
               </a:rPr>
-              <a:t>843 автотеста проходят, каждое число воспроизводится командой</a:t>
+              <a:t>858 автотестов проходят, каждое число воспроизводится командой</a:t>
             </a:r>
             <a:endParaRPr lang="en-US" sz="1500" dirty="0"/>
           </a:p>
@@ -23545,7 +23545,7 @@
                           <a:ea typeface="Calibri" pitchFamily="34" charset="-122"/>
                           <a:cs typeface="Calibri" pitchFamily="34" charset="-120"/>
                         </a:rPr>
-                        <a:t>843 автотеста проходят (v0.3.0, evidence.json), независимая проверка на Cedar, реестр утверждений: каждое число воспроизводится командой</a:t>
+                        <a:t>858 автотестов проходят (v0.3.0, evidence.json), независимая проверка на Cedar, реестр утверждений: каждое число воспроизводится командой</a:t>
                       </a:r>
                       <a:endParaRPr lang="en-US" sz="1300" dirty="0">
                         <a:latin typeface="Calibri" charset="0"/>

</xml_diff>

<commit_message>
anchor: witness cosignatures (C2SP tlog-cosignature) and Sigstore TrustedRoot/SigningConfig via TUF (#4)
Co-authored-by: KonkovDV <KonkovDV@users.noreply.github.com>
</commit_message>
<xml_diff>
--- a/submission/slides/Mandat_VTB.pptx
+++ b/submission/slides/Mandat_VTB.pptx
@@ -133,7 +133,7 @@
   <p:extLst>
     <p:ext uri="{521415D9-36F7-43E2-AB2F-B90AF26B5E84}">
       <p14:sectionLst xmlns:p14="http://schemas.microsoft.com/office/powerpoint/2010/main">
-        <p14:section name="Питч · 5 минут" id="{9770c435-96f5-4b2f-3590-68d222b0a4dc}">
+        <p14:section name="Питч · 5 минут" id="{fcfb8e35-0ca8-951b-6f4b-f5d068a1c836}">
           <p14:sldIdLst>
             <p14:sldId id="256"/>
             <p14:sldId id="257"/>
@@ -151,7 +151,7 @@
             <p14:sldId id="269"/>
           </p14:sldIdLst>
         </p14:section>
-        <p14:section name="Приложение для вопросов жюри" id="{f2cec953-0b8c-b7f2-584f-625c45fc31be}">
+        <p14:section name="Приложение для вопросов жюри" id="{e5022ebd-4817-3d3c-2e1b-ec8adceee6ee}">
           <p14:sldIdLst>
             <p14:sldId id="270"/>
             <p14:sldId id="271"/>
@@ -6093,7 +6093,7 @@
                   <a:schemeClr val="accent4"/>
                 </a:solidFill>
               </a:rPr>
-              <a:t>Источники: vtb.ru — «Комплект МЧД и КЭП» в «ВТБ Бизнес», 10.2026; репозиторий «Мандата» v0.3.0: 843 автотеста, evidence.json от 14.10.2026</a:t>
+              <a:t>Источники: vtb.ru — «Комплект МЧД и КЭП» в «ВТБ Бизнес», 10.2026; репозиторий «Мандата» v0.3.0: 858 автотестов, evidence.json от 14.10.2026</a:t>
             </a:r>
             <a:endParaRPr lang="en-US" sz="1000" dirty="0"/>
           </a:p>
@@ -6956,7 +6956,7 @@
                   <a:schemeClr val="bg1"/>
                 </a:solidFill>
               </a:rPr>
-              <a:t>843 автотеста проходят, каждое число воспроизводится командой</a:t>
+              <a:t>858 автотестов проходят, каждое число воспроизводится командой</a:t>
             </a:r>
             <a:endParaRPr lang="en-US" sz="1500" dirty="0"/>
           </a:p>
@@ -23545,7 +23545,7 @@
                           <a:ea typeface="Calibri" pitchFamily="34" charset="-122"/>
                           <a:cs typeface="Calibri" pitchFamily="34" charset="-120"/>
                         </a:rPr>
-                        <a:t>843 автотеста проходят (v0.3.0, evidence.json), независимая проверка на Cedar, реестр утверждений: каждое число воспроизводится командой</a:t>
+                        <a:t>858 автотестов проходят (v0.3.0, evidence.json), независимая проверка на Cedar, реестр утверждений: каждое число воспроизводится командой</a:t>
                       </a:r>
                       <a:endParaRPr lang="en-US" sz="1300" dirty="0">
                         <a:latin typeface="Calibri" charset="0"/>

</xml_diff>

<commit_message>
webhooks: Standard Webhooks v1a (Ed25519) signing; read-back verified with receiver public key
</commit_message>
<xml_diff>
--- a/submission/slides/Mandat_VTB.pptx
+++ b/submission/slides/Mandat_VTB.pptx
@@ -133,7 +133,7 @@
   <p:extLst>
     <p:ext uri="{521415D9-36F7-43E2-AB2F-B90AF26B5E84}">
       <p14:sectionLst xmlns:p14="http://schemas.microsoft.com/office/powerpoint/2010/main">
-        <p14:section name="Питч · 5 минут" id="{fcfb8e35-0ca8-951b-6f4b-f5d068a1c836}">
+        <p14:section name="Питч · 5 минут" id="{7e7ced5b-b294-a64f-536f-db0ad63a65ac}">
           <p14:sldIdLst>
             <p14:sldId id="256"/>
             <p14:sldId id="257"/>
@@ -151,7 +151,7 @@
             <p14:sldId id="269"/>
           </p14:sldIdLst>
         </p14:section>
-        <p14:section name="Приложение для вопросов жюри" id="{e5022ebd-4817-3d3c-2e1b-ec8adceee6ee}">
+        <p14:section name="Приложение для вопросов жюри" id="{349a1b66-d1fd-4c3a-005d-a9d95a084287}">
           <p14:sldIdLst>
             <p14:sldId id="270"/>
             <p14:sldId id="271"/>
@@ -6093,7 +6093,7 @@
                   <a:schemeClr val="accent4"/>
                 </a:solidFill>
               </a:rPr>
-              <a:t>Источники: vtb.ru — «Комплект МЧД и КЭП» в «ВТБ Бизнес», 10.2026; репозиторий «Мандата» v0.3.0: 858 автотестов, evidence.json от 14.10.2026</a:t>
+              <a:t>Источники: vtb.ru — «Комплект МЧД и КЭП» в «ВТБ Бизнес», 10.2026; репозиторий «Мандата» v0.3.0: 865 автотестов, evidence.json от 14.10.2026</a:t>
             </a:r>
             <a:endParaRPr lang="en-US" sz="1000" dirty="0"/>
           </a:p>
@@ -6956,7 +6956,7 @@
                   <a:schemeClr val="bg1"/>
                 </a:solidFill>
               </a:rPr>
-              <a:t>858 автотестов проходят, каждое число воспроизводится командой</a:t>
+              <a:t>865 автотестов проходят, каждое число воспроизводится командой</a:t>
             </a:r>
             <a:endParaRPr lang="en-US" sz="1500" dirty="0"/>
           </a:p>
@@ -23545,7 +23545,7 @@
                           <a:ea typeface="Calibri" pitchFamily="34" charset="-122"/>
                           <a:cs typeface="Calibri" pitchFamily="34" charset="-120"/>
                         </a:rPr>
-                        <a:t>858 автотестов проходят (v0.3.0, evidence.json), независимая проверка на Cedar, реестр утверждений: каждое число воспроизводится командой</a:t>
+                        <a:t>865 автотестов проходят (v0.3.0, evidence.json), независимая проверка на Cedar, реестр утверждений: каждое число воспроизводится командой</a:t>
                       </a:r>
                       <a:endParaRPr lang="en-US" sz="1300" dirty="0">
                         <a:latin typeface="Calibri" charset="0"/>

</xml_diff>

<commit_message>
webhooks: Standard Webhooks v1a (Ed25519) signing; read-back verified with receiver public key (#5)
Co-authored-by: KonkovDV <KonkovDV@users.noreply.github.com>
</commit_message>
<xml_diff>
--- a/submission/slides/Mandat_VTB.pptx
+++ b/submission/slides/Mandat_VTB.pptx
@@ -133,7 +133,7 @@
   <p:extLst>
     <p:ext uri="{521415D9-36F7-43E2-AB2F-B90AF26B5E84}">
       <p14:sectionLst xmlns:p14="http://schemas.microsoft.com/office/powerpoint/2010/main">
-        <p14:section name="Питч · 5 минут" id="{fcfb8e35-0ca8-951b-6f4b-f5d068a1c836}">
+        <p14:section name="Питч · 5 минут" id="{7e7ced5b-b294-a64f-536f-db0ad63a65ac}">
           <p14:sldIdLst>
             <p14:sldId id="256"/>
             <p14:sldId id="257"/>
@@ -151,7 +151,7 @@
             <p14:sldId id="269"/>
           </p14:sldIdLst>
         </p14:section>
-        <p14:section name="Приложение для вопросов жюри" id="{e5022ebd-4817-3d3c-2e1b-ec8adceee6ee}">
+        <p14:section name="Приложение для вопросов жюри" id="{349a1b66-d1fd-4c3a-005d-a9d95a084287}">
           <p14:sldIdLst>
             <p14:sldId id="270"/>
             <p14:sldId id="271"/>
@@ -6093,7 +6093,7 @@
                   <a:schemeClr val="accent4"/>
                 </a:solidFill>
               </a:rPr>
-              <a:t>Источники: vtb.ru — «Комплект МЧД и КЭП» в «ВТБ Бизнес», 10.2026; репозиторий «Мандата» v0.3.0: 858 автотестов, evidence.json от 14.10.2026</a:t>
+              <a:t>Источники: vtb.ru — «Комплект МЧД и КЭП» в «ВТБ Бизнес», 10.2026; репозиторий «Мандата» v0.3.0: 865 автотестов, evidence.json от 14.10.2026</a:t>
             </a:r>
             <a:endParaRPr lang="en-US" sz="1000" dirty="0"/>
           </a:p>
@@ -6956,7 +6956,7 @@
                   <a:schemeClr val="bg1"/>
                 </a:solidFill>
               </a:rPr>
-              <a:t>858 автотестов проходят, каждое число воспроизводится командой</a:t>
+              <a:t>865 автотестов проходят, каждое число воспроизводится командой</a:t>
             </a:r>
             <a:endParaRPr lang="en-US" sz="1500" dirty="0"/>
           </a:p>
@@ -23545,7 +23545,7 @@
                           <a:ea typeface="Calibri" pitchFamily="34" charset="-122"/>
                           <a:cs typeface="Calibri" pitchFamily="34" charset="-120"/>
                         </a:rPr>
-                        <a:t>858 автотестов проходят (v0.3.0, evidence.json), независимая проверка на Cedar, реестр утверждений: каждое число воспроизводится командой</a:t>
+                        <a:t>865 автотестов проходят (v0.3.0, evidence.json), независимая проверка на Cedar, реестр утверждений: каждое число воспроизводится командой</a:t>
                       </a:r>
                       <a:endParaRPr lang="en-US" sz="1300" dirty="0">
                         <a:latin typeface="Calibri" charset="0"/>

</xml_diff>

<commit_message>
jury pass: executable run-demo.sh, compose passes documented env and is smoke-tested in CI, fresh demo cards, README first screen, docs/JURY.md
</commit_message>
<xml_diff>
--- a/submission/slides/Mandat_VTB.pptx
+++ b/submission/slides/Mandat_VTB.pptx
@@ -133,7 +133,7 @@
   <p:extLst>
     <p:ext uri="{521415D9-36F7-43E2-AB2F-B90AF26B5E84}">
       <p14:sectionLst xmlns:p14="http://schemas.microsoft.com/office/powerpoint/2010/main">
-        <p14:section name="Питч · 5 минут" id="{7e7ced5b-b294-a64f-536f-db0ad63a65ac}">
+        <p14:section name="Питч · 5 минут" id="{37305143-3b01-8f9a-f487-04bbd0dca965}">
           <p14:sldIdLst>
             <p14:sldId id="256"/>
             <p14:sldId id="257"/>
@@ -151,7 +151,7 @@
             <p14:sldId id="269"/>
           </p14:sldIdLst>
         </p14:section>
-        <p14:section name="Приложение для вопросов жюри" id="{349a1b66-d1fd-4c3a-005d-a9d95a084287}">
+        <p14:section name="Приложение для вопросов жюри" id="{68c3a76b-b1b4-eda4-2adb-cc3218d8be7d}">
           <p14:sldIdLst>
             <p14:sldId id="270"/>
             <p14:sldId id="271"/>

</xml_diff>

<commit_message>
jury pass: executable run-demo.sh, compose passes documented env and is smoke-tested in CI, fresh demo cards, README first screen, docs/JURY.md (#6)
Co-authored-by: KonkovDV <KonkovDV@users.noreply.github.com>
</commit_message>
<xml_diff>
--- a/submission/slides/Mandat_VTB.pptx
+++ b/submission/slides/Mandat_VTB.pptx
@@ -133,7 +133,7 @@
   <p:extLst>
     <p:ext uri="{521415D9-36F7-43E2-AB2F-B90AF26B5E84}">
       <p14:sectionLst xmlns:p14="http://schemas.microsoft.com/office/powerpoint/2010/main">
-        <p14:section name="Питч · 5 минут" id="{7e7ced5b-b294-a64f-536f-db0ad63a65ac}">
+        <p14:section name="Питч · 5 минут" id="{37305143-3b01-8f9a-f487-04bbd0dca965}">
           <p14:sldIdLst>
             <p14:sldId id="256"/>
             <p14:sldId id="257"/>
@@ -151,7 +151,7 @@
             <p14:sldId id="269"/>
           </p14:sldIdLst>
         </p14:section>
-        <p14:section name="Приложение для вопросов жюри" id="{349a1b66-d1fd-4c3a-005d-a9d95a084287}">
+        <p14:section name="Приложение для вопросов жюри" id="{68c3a76b-b1b4-eda4-2adb-cc3218d8be7d}">
           <p14:sldIdLst>
             <p14:sldId id="270"/>
             <p14:sldId id="271"/>

</xml_diff>

<commit_message>
audit R3: TSA revocation CRL cache keyed by issuer, no redirects, URL cap; deck deps (sharp, image-size); npm in Dependabot; AUDIT-2026-10-14-R3
</commit_message>
<xml_diff>
--- a/submission/slides/Mandat_VTB.pptx
+++ b/submission/slides/Mandat_VTB.pptx
@@ -134,7 +134,7 @@
   <p:extLst>
     <p:ext uri="{521415D9-36F7-43E2-AB2F-B90AF26B5E84}">
       <p14:sectionLst xmlns:p14="http://schemas.microsoft.com/office/powerpoint/2010/main">
-        <p14:section name="Питч · 5 минут" id="{5a462cf0-9153-9a8d-6d21-d4fb6511e949}">
+        <p14:section name="Питч · 5 минут" id="{3df47ef4-420e-6e95-a2e3-4b3b67f10f52}">
           <p14:sldIdLst>
             <p14:sldId id="256"/>
             <p14:sldId id="257"/>
@@ -152,7 +152,7 @@
             <p14:sldId id="269"/>
           </p14:sldIdLst>
         </p14:section>
-        <p14:section name="Приложение для вопросов жюри" id="{769ae120-6d54-edac-92a0-07f3dbe558e4}">
+        <p14:section name="Приложение для вопросов жюри" id="{048acd47-2ab3-4332-e2e4-e8823dc6d38f}">
           <p14:sldIdLst>
             <p14:sldId id="270"/>
             <p14:sldId id="271"/>
@@ -6183,7 +6183,7 @@
                   <a:schemeClr val="accent4"/>
                 </a:solidFill>
               </a:rPr>
-              <a:t>Источники: vtb.ru — «Комплект МЧД и КЭП» в «ВТБ Бизнес», 10.2026; репозиторий «Мандата» v0.3.0: 869 автотестов, evidence.json от 14.10.2026</a:t>
+              <a:t>Источники: vtb.ru — «Комплект МЧД и КЭП» в «ВТБ Бизнес», 10.2026; репозиторий «Мандата» v0.3.0: 872 автотеста, evidence.json от 15.10.2026</a:t>
             </a:r>
             <a:endParaRPr lang="en-US" sz="1000" dirty="0"/>
           </a:p>
@@ -7046,7 +7046,7 @@
                   <a:schemeClr val="bg1"/>
                 </a:solidFill>
               </a:rPr>
-              <a:t>869 автотестов проходят, каждое число воспроизводится командой</a:t>
+              <a:t>872 автотеста проходят, каждое число воспроизводится командой</a:t>
             </a:r>
             <a:endParaRPr lang="en-US" sz="1500" dirty="0"/>
           </a:p>
@@ -12430,7 +12430,7 @@
                           <a:ea typeface="Calibri" pitchFamily="34" charset="-122"/>
                           <a:cs typeface="Calibri" pitchFamily="34" charset="-120"/>
                         </a:rPr>
-                        <a:t>869 автотестов; evidence.json</a:t>
+                        <a:t>872 автотестов; evidence.json</a:t>
                       </a:r>
                       <a:endParaRPr lang="en-US" sz="1400" dirty="0">
                         <a:latin typeface="Calibri" charset="0"/>
@@ -25390,7 +25390,7 @@
                           <a:ea typeface="Calibri" pitchFamily="34" charset="-122"/>
                           <a:cs typeface="Calibri" pitchFamily="34" charset="-120"/>
                         </a:rPr>
-                        <a:t>869 автотестов проходят (v0.3.0, evidence.json), независимая проверка на Cedar, реестр утверждений: каждое число воспроизводится командой</a:t>
+                        <a:t>872 автотеста проходят (v0.3.0, evidence.json), независимая проверка на Cedar, реестр утверждений: каждое число воспроизводится командой</a:t>
                       </a:r>
                       <a:endParaRPr lang="en-US" sz="1300" dirty="0">
                         <a:latin typeface="Calibri" charset="0"/>
@@ -33386,7 +33386,7 @@
                   <a:schemeClr val="accent4"/>
                 </a:solidFill>
               </a:rPr>
-              <a:t>Воспроизводится: mandat eval --per-defect 6; python -m pytest tests/test_properties.py tests/test_cedar.py; python scripts/bench.py → evidence.json (14.10.2026, v0.3.0)</a:t>
+              <a:t>Воспроизводится: mandat eval --per-defect 6; python -m pytest tests/test_properties.py tests/test_cedar.py; python scripts/bench.py → evidence.json (15.10.2026, v0.3.0)</a:t>
             </a:r>
             <a:endParaRPr lang="en-US" sz="1000" dirty="0"/>
           </a:p>
@@ -33774,7 +33774,7 @@
                   <a:schemeClr val="accent1"/>
                 </a:solidFill>
               </a:rPr>
-              <a:t>≈2 мс</a:t>
+              <a:t>≈1 мс</a:t>
             </a:r>
             <a:endParaRPr lang="en-US" sz="3000" dirty="0"/>
           </a:p>

</xml_diff>

<commit_message>
audit R3: TSA revocation CRL cache keyed by issuer, no redirects, URL cap; deck deps (sharp, image-size); npm in Dependabot; AUDIT-2026-10-14-R3 (#12)
Co-authored-by: KonkovDV <KonkovDV@users.noreply.github.com>
</commit_message>
<xml_diff>
--- a/submission/slides/Mandat_VTB.pptx
+++ b/submission/slides/Mandat_VTB.pptx
@@ -134,7 +134,7 @@
   <p:extLst>
     <p:ext uri="{521415D9-36F7-43E2-AB2F-B90AF26B5E84}">
       <p14:sectionLst xmlns:p14="http://schemas.microsoft.com/office/powerpoint/2010/main">
-        <p14:section name="Питч · 5 минут" id="{5a462cf0-9153-9a8d-6d21-d4fb6511e949}">
+        <p14:section name="Питч · 5 минут" id="{3df47ef4-420e-6e95-a2e3-4b3b67f10f52}">
           <p14:sldIdLst>
             <p14:sldId id="256"/>
             <p14:sldId id="257"/>
@@ -152,7 +152,7 @@
             <p14:sldId id="269"/>
           </p14:sldIdLst>
         </p14:section>
-        <p14:section name="Приложение для вопросов жюри" id="{769ae120-6d54-edac-92a0-07f3dbe558e4}">
+        <p14:section name="Приложение для вопросов жюри" id="{048acd47-2ab3-4332-e2e4-e8823dc6d38f}">
           <p14:sldIdLst>
             <p14:sldId id="270"/>
             <p14:sldId id="271"/>
@@ -6183,7 +6183,7 @@
                   <a:schemeClr val="accent4"/>
                 </a:solidFill>
               </a:rPr>
-              <a:t>Источники: vtb.ru — «Комплект МЧД и КЭП» в «ВТБ Бизнес», 10.2026; репозиторий «Мандата» v0.3.0: 869 автотестов, evidence.json от 14.10.2026</a:t>
+              <a:t>Источники: vtb.ru — «Комплект МЧД и КЭП» в «ВТБ Бизнес», 10.2026; репозиторий «Мандата» v0.3.0: 872 автотеста, evidence.json от 15.10.2026</a:t>
             </a:r>
             <a:endParaRPr lang="en-US" sz="1000" dirty="0"/>
           </a:p>
@@ -7046,7 +7046,7 @@
                   <a:schemeClr val="bg1"/>
                 </a:solidFill>
               </a:rPr>
-              <a:t>869 автотестов проходят, каждое число воспроизводится командой</a:t>
+              <a:t>872 автотеста проходят, каждое число воспроизводится командой</a:t>
             </a:r>
             <a:endParaRPr lang="en-US" sz="1500" dirty="0"/>
           </a:p>
@@ -12430,7 +12430,7 @@
                           <a:ea typeface="Calibri" pitchFamily="34" charset="-122"/>
                           <a:cs typeface="Calibri" pitchFamily="34" charset="-120"/>
                         </a:rPr>
-                        <a:t>869 автотестов; evidence.json</a:t>
+                        <a:t>872 автотестов; evidence.json</a:t>
                       </a:r>
                       <a:endParaRPr lang="en-US" sz="1400" dirty="0">
                         <a:latin typeface="Calibri" charset="0"/>
@@ -25390,7 +25390,7 @@
                           <a:ea typeface="Calibri" pitchFamily="34" charset="-122"/>
                           <a:cs typeface="Calibri" pitchFamily="34" charset="-120"/>
                         </a:rPr>
-                        <a:t>869 автотестов проходят (v0.3.0, evidence.json), независимая проверка на Cedar, реестр утверждений: каждое число воспроизводится командой</a:t>
+                        <a:t>872 автотеста проходят (v0.3.0, evidence.json), независимая проверка на Cedar, реестр утверждений: каждое число воспроизводится командой</a:t>
                       </a:r>
                       <a:endParaRPr lang="en-US" sz="1300" dirty="0">
                         <a:latin typeface="Calibri" charset="0"/>
@@ -33386,7 +33386,7 @@
                   <a:schemeClr val="accent4"/>
                 </a:solidFill>
               </a:rPr>
-              <a:t>Воспроизводится: mandat eval --per-defect 6; python -m pytest tests/test_properties.py tests/test_cedar.py; python scripts/bench.py → evidence.json (14.10.2026, v0.3.0)</a:t>
+              <a:t>Воспроизводится: mandat eval --per-defect 6; python -m pytest tests/test_properties.py tests/test_cedar.py; python scripts/bench.py → evidence.json (15.10.2026, v0.3.0)</a:t>
             </a:r>
             <a:endParaRPr lang="en-US" sz="1000" dirty="0"/>
           </a:p>
@@ -33774,7 +33774,7 @@
                   <a:schemeClr val="accent1"/>
                 </a:solidFill>
               </a:rPr>
-              <a:t>≈2 мс</a:t>
+              <a:t>≈1 мс</a:t>
             </a:r>
             <a:endParaRPr lang="en-US" sz="3000" dirty="0"/>
           </a:p>

</xml_diff>

<commit_message>
R4: registry query by number+principal INN+representative INN; committed OpenAPI contract and route-protection test; SOTA 15.10, portfolio ideas, AUDIT-2026-10-15-R4
</commit_message>
<xml_diff>
--- a/submission/slides/Mandat_VTB.pptx
+++ b/submission/slides/Mandat_VTB.pptx
@@ -134,7 +134,7 @@
   <p:extLst>
     <p:ext uri="{521415D9-36F7-43E2-AB2F-B90AF26B5E84}">
       <p14:sectionLst xmlns:p14="http://schemas.microsoft.com/office/powerpoint/2010/main">
-        <p14:section name="Питч · 5 минут" id="{3df47ef4-420e-6e95-a2e3-4b3b67f10f52}">
+        <p14:section name="Питч · 5 минут" id="{bf049bfa-fff5-51ef-4412-d1d630dbd9dd}">
           <p14:sldIdLst>
             <p14:sldId id="256"/>
             <p14:sldId id="257"/>
@@ -152,7 +152,7 @@
             <p14:sldId id="269"/>
           </p14:sldIdLst>
         </p14:section>
-        <p14:section name="Приложение для вопросов жюри" id="{048acd47-2ab3-4332-e2e4-e8823dc6d38f}">
+        <p14:section name="Приложение для вопросов жюри" id="{9d0f4b84-f520-30d7-0002-57ae94ba881e}">
           <p14:sldIdLst>
             <p14:sldId id="270"/>
             <p14:sldId id="271"/>
@@ -6183,7 +6183,7 @@
                   <a:schemeClr val="accent4"/>
                 </a:solidFill>
               </a:rPr>
-              <a:t>Источники: vtb.ru — «Комплект МЧД и КЭП» в «ВТБ Бизнес», 10.2026; репозиторий «Мандата» v0.3.0: 872 автотеста, evidence.json от 15.10.2026</a:t>
+              <a:t>Источники: vtb.ru — «Комплект МЧД и КЭП» в «ВТБ Бизнес», 10.2026; репозиторий «Мандата» v0.3.0: 878 автотестов, evidence.json от 15.10.2026</a:t>
             </a:r>
             <a:endParaRPr lang="en-US" sz="1000" dirty="0"/>
           </a:p>
@@ -7046,7 +7046,7 @@
                   <a:schemeClr val="bg1"/>
                 </a:solidFill>
               </a:rPr>
-              <a:t>872 автотеста проходят, каждое число воспроизводится командой</a:t>
+              <a:t>878 автотестов проходят, каждое число воспроизводится командой</a:t>
             </a:r>
             <a:endParaRPr lang="en-US" sz="1500" dirty="0"/>
           </a:p>
@@ -12430,7 +12430,7 @@
                           <a:ea typeface="Calibri" pitchFamily="34" charset="-122"/>
                           <a:cs typeface="Calibri" pitchFamily="34" charset="-120"/>
                         </a:rPr>
-                        <a:t>872 автотестов; evidence.json</a:t>
+                        <a:t>878 автотестов; evidence.json</a:t>
                       </a:r>
                       <a:endParaRPr lang="en-US" sz="1400" dirty="0">
                         <a:latin typeface="Calibri" charset="0"/>
@@ -25390,7 +25390,7 @@
                           <a:ea typeface="Calibri" pitchFamily="34" charset="-122"/>
                           <a:cs typeface="Calibri" pitchFamily="34" charset="-120"/>
                         </a:rPr>
-                        <a:t>872 автотеста проходят (v0.3.0, evidence.json), независимая проверка на Cedar, реестр утверждений: каждое число воспроизводится командой</a:t>
+                        <a:t>878 автотестов проходят (v0.3.0, evidence.json), независимая проверка на Cedar, реестр утверждений: каждое число воспроизводится командой</a:t>
                       </a:r>
                       <a:endParaRPr lang="en-US" sz="1300" dirty="0">
                         <a:latin typeface="Calibri" charset="0"/>
@@ -33774,7 +33774,7 @@
                   <a:schemeClr val="accent1"/>
                 </a:solidFill>
               </a:rPr>
-              <a:t>≈1 мс</a:t>
+              <a:t>≈2 мс</a:t>
             </a:r>
             <a:endParaRPr lang="en-US" sz="3000" dirty="0"/>
           </a:p>

</xml_diff>

<commit_message>
R4: registry query by number+principal INN+representative INN; committed OpenAPI contract and route-protection test; SOTA 15.10, portfolio ideas, AUDIT-2026-10-15-R4 (#15)
Co-authored-by: KonkovDV <KonkovDV@users.noreply.github.com>
</commit_message>
<xml_diff>
--- a/submission/slides/Mandat_VTB.pptx
+++ b/submission/slides/Mandat_VTB.pptx
@@ -134,7 +134,7 @@
   <p:extLst>
     <p:ext uri="{521415D9-36F7-43E2-AB2F-B90AF26B5E84}">
       <p14:sectionLst xmlns:p14="http://schemas.microsoft.com/office/powerpoint/2010/main">
-        <p14:section name="Питч · 5 минут" id="{3df47ef4-420e-6e95-a2e3-4b3b67f10f52}">
+        <p14:section name="Питч · 5 минут" id="{bf049bfa-fff5-51ef-4412-d1d630dbd9dd}">
           <p14:sldIdLst>
             <p14:sldId id="256"/>
             <p14:sldId id="257"/>
@@ -152,7 +152,7 @@
             <p14:sldId id="269"/>
           </p14:sldIdLst>
         </p14:section>
-        <p14:section name="Приложение для вопросов жюри" id="{048acd47-2ab3-4332-e2e4-e8823dc6d38f}">
+        <p14:section name="Приложение для вопросов жюри" id="{9d0f4b84-f520-30d7-0002-57ae94ba881e}">
           <p14:sldIdLst>
             <p14:sldId id="270"/>
             <p14:sldId id="271"/>
@@ -6183,7 +6183,7 @@
                   <a:schemeClr val="accent4"/>
                 </a:solidFill>
               </a:rPr>
-              <a:t>Источники: vtb.ru — «Комплект МЧД и КЭП» в «ВТБ Бизнес», 10.2026; репозиторий «Мандата» v0.3.0: 872 автотеста, evidence.json от 15.10.2026</a:t>
+              <a:t>Источники: vtb.ru — «Комплект МЧД и КЭП» в «ВТБ Бизнес», 10.2026; репозиторий «Мандата» v0.3.0: 878 автотестов, evidence.json от 15.10.2026</a:t>
             </a:r>
             <a:endParaRPr lang="en-US" sz="1000" dirty="0"/>
           </a:p>
@@ -7046,7 +7046,7 @@
                   <a:schemeClr val="bg1"/>
                 </a:solidFill>
               </a:rPr>
-              <a:t>872 автотеста проходят, каждое число воспроизводится командой</a:t>
+              <a:t>878 автотестов проходят, каждое число воспроизводится командой</a:t>
             </a:r>
             <a:endParaRPr lang="en-US" sz="1500" dirty="0"/>
           </a:p>
@@ -12430,7 +12430,7 @@
                           <a:ea typeface="Calibri" pitchFamily="34" charset="-122"/>
                           <a:cs typeface="Calibri" pitchFamily="34" charset="-120"/>
                         </a:rPr>
-                        <a:t>872 автотестов; evidence.json</a:t>
+                        <a:t>878 автотестов; evidence.json</a:t>
                       </a:r>
                       <a:endParaRPr lang="en-US" sz="1400" dirty="0">
                         <a:latin typeface="Calibri" charset="0"/>
@@ -25390,7 +25390,7 @@
                           <a:ea typeface="Calibri" pitchFamily="34" charset="-122"/>
                           <a:cs typeface="Calibri" pitchFamily="34" charset="-120"/>
                         </a:rPr>
-                        <a:t>872 автотеста проходят (v0.3.0, evidence.json), независимая проверка на Cedar, реестр утверждений: каждое число воспроизводится командой</a:t>
+                        <a:t>878 автотестов проходят (v0.3.0, evidence.json), независимая проверка на Cedar, реестр утверждений: каждое число воспроизводится командой</a:t>
                       </a:r>
                       <a:endParaRPr lang="en-US" sz="1300" dirty="0">
                         <a:latin typeface="Calibri" charset="0"/>
@@ -33774,7 +33774,7 @@
                   <a:schemeClr val="accent1"/>
                 </a:solidFill>
               </a:rPr>
-              <a:t>≈1 мс</a:t>
+              <a:t>≈2 мс</a:t>
             </a:r>
             <a:endParaRPr lang="en-US" sz="3000" dirty="0"/>
           </a:p>

</xml_diff>

<commit_message>
wip: evidence 936, deck
</commit_message>
<xml_diff>
--- a/submission/slides/Mandat_VTB.pptx
+++ b/submission/slides/Mandat_VTB.pptx
@@ -134,7 +134,7 @@
   <p:extLst>
     <p:ext uri="{521415D9-36F7-43E2-AB2F-B90AF26B5E84}">
       <p14:sectionLst xmlns:p14="http://schemas.microsoft.com/office/powerpoint/2010/main">
-        <p14:section name="Питч · 5 минут" id="{bf049bfa-fff5-51ef-4412-d1d630dbd9dd}">
+        <p14:section name="Питч · 5 минут" id="{4693a4b6-3a05-6f31-48a7-615288a39605}">
           <p14:sldIdLst>
             <p14:sldId id="256"/>
             <p14:sldId id="257"/>
@@ -152,7 +152,7 @@
             <p14:sldId id="269"/>
           </p14:sldIdLst>
         </p14:section>
-        <p14:section name="Приложение для вопросов жюри" id="{9d0f4b84-f520-30d7-0002-57ae94ba881e}">
+        <p14:section name="Приложение для вопросов жюри" id="{22ce0d31-22ab-9efa-fc1c-08ab3f32df5e}">
           <p14:sldIdLst>
             <p14:sldId id="270"/>
             <p14:sldId id="271"/>
@@ -6183,7 +6183,7 @@
                   <a:schemeClr val="accent4"/>
                 </a:solidFill>
               </a:rPr>
-              <a:t>Источники: vtb.ru — «Комплект МЧД и КЭП» в «ВТБ Бизнес», 10.2026; репозиторий «Мандата» v0.3.0: 878 автотестов, evidence.json от 15.10.2026</a:t>
+              <a:t>Источники: vtb.ru — «Комплект МЧД и КЭП» в «ВТБ Бизнес», 10.2026; репозиторий «Мандата» v0.3.0: 936 автотестов, evidence.json от 15.10.2026</a:t>
             </a:r>
             <a:endParaRPr lang="en-US" sz="1000" dirty="0"/>
           </a:p>
@@ -7046,7 +7046,7 @@
                   <a:schemeClr val="bg1"/>
                 </a:solidFill>
               </a:rPr>
-              <a:t>878 автотестов проходят, каждое число воспроизводится командой</a:t>
+              <a:t>936 автотестов проходят, каждое число воспроизводится командой</a:t>
             </a:r>
             <a:endParaRPr lang="en-US" sz="1500" dirty="0"/>
           </a:p>
@@ -12430,7 +12430,7 @@
                           <a:ea typeface="Calibri" pitchFamily="34" charset="-122"/>
                           <a:cs typeface="Calibri" pitchFamily="34" charset="-120"/>
                         </a:rPr>
-                        <a:t>878 автотестов; evidence.json</a:t>
+                        <a:t>936 автотестов; evidence.json</a:t>
                       </a:r>
                       <a:endParaRPr lang="en-US" sz="1400" dirty="0">
                         <a:latin typeface="Calibri" charset="0"/>
@@ -25390,7 +25390,7 @@
                           <a:ea typeface="Calibri" pitchFamily="34" charset="-122"/>
                           <a:cs typeface="Calibri" pitchFamily="34" charset="-120"/>
                         </a:rPr>
-                        <a:t>878 автотестов проходят (v0.3.0, evidence.json), независимая проверка на Cedar, реестр утверждений: каждое число воспроизводится командой</a:t>
+                        <a:t>936 автотестов проходят (v0.3.0, evidence.json), независимая проверка на Cedar, реестр утверждений: каждое число воспроизводится командой</a:t>
                       </a:r>
                       <a:endParaRPr lang="en-US" sz="1300" dirty="0">
                         <a:latin typeface="Calibri" charset="0"/>

</xml_diff>

<commit_message>
fix(M-01/M-02): fail-closed attestation status + flock CAS revocation (#18)
M-01: fail-closed status_dir; crypto-only never says «принимается».
M-02: flock + OR-merge + CURRENT; Ваня blockers closed.
Claims synced to evidence.json: 993 автотестов, 95.8% coverage.
</commit_message>
<xml_diff>
--- a/submission/slides/Mandat_VTB.pptx
+++ b/submission/slides/Mandat_VTB.pptx
@@ -134,7 +134,7 @@
   <p:extLst>
     <p:ext uri="{521415D9-36F7-43E2-AB2F-B90AF26B5E84}">
       <p14:sectionLst xmlns:p14="http://schemas.microsoft.com/office/powerpoint/2010/main">
-        <p14:section name="Питч · 5 минут" id="{d18d559b-aa83-6f86-e8b6-f96edbe0e93b}">
+        <p14:section name="Питч · 5 минут" id="{a9219409-316c-49ef-ba47-e716a756a317}">
           <p14:sldIdLst>
             <p14:sldId id="256"/>
             <p14:sldId id="257"/>
@@ -152,7 +152,7 @@
             <p14:sldId id="269"/>
           </p14:sldIdLst>
         </p14:section>
-        <p14:section name="Приложение для вопросов жюри" id="{2e56231e-05e3-792c-ddcc-e3169e5f4541}">
+        <p14:section name="Приложение для вопросов жюри" id="{2a89f822-9bc9-6891-0459-870cdbc324e8}">
           <p14:sldIdLst>
             <p14:sldId id="270"/>
             <p14:sldId id="271"/>
@@ -6183,7 +6183,7 @@
                   <a:schemeClr val="accent4"/>
                 </a:solidFill>
               </a:rPr>
-              <a:t>Источники: vtb.ru — «Комплект МЧД и КЭП» в «ВТБ Бизнес», 10.2026; репозиторий «Мандата» v0.3.0: 960 автотестов, evidence.json от 15.10.2026</a:t>
+              <a:t>Источники: vtb.ru — «Комплект МЧД и КЭП» в «ВТБ Бизнес», 10.2026; репозиторий «Мандата» v0.3.0: 993 автотеста, evidence.json от 15.10.2026</a:t>
             </a:r>
             <a:endParaRPr lang="en-US" sz="1000" dirty="0"/>
           </a:p>
@@ -7046,7 +7046,7 @@
                   <a:schemeClr val="bg1"/>
                 </a:solidFill>
               </a:rPr>
-              <a:t>960 автотестов проходят, каждое число воспроизводится командой</a:t>
+              <a:t>993 автотеста проходят, каждое число воспроизводится командой</a:t>
             </a:r>
             <a:endParaRPr lang="en-US" sz="1500" dirty="0"/>
           </a:p>
@@ -12430,7 +12430,7 @@
                           <a:ea typeface="Calibri" pitchFamily="34" charset="-122"/>
                           <a:cs typeface="Calibri" pitchFamily="34" charset="-120"/>
                         </a:rPr>
-                        <a:t>960 автотестов; evidence.json</a:t>
+                        <a:t>993 автотестов; evidence.json</a:t>
                       </a:r>
                       <a:endParaRPr lang="en-US" sz="1400" dirty="0">
                         <a:latin typeface="Calibri" charset="0"/>
@@ -25390,7 +25390,7 @@
                           <a:ea typeface="Calibri" pitchFamily="34" charset="-122"/>
                           <a:cs typeface="Calibri" pitchFamily="34" charset="-120"/>
                         </a:rPr>
-                        <a:t>960 автотестов проходят (v0.3.0, evidence.json), независимая проверка на Cedar, реестр утверждений: каждое число воспроизводится командой</a:t>
+                        <a:t>993 автотеста проходят (v0.3.0, evidence.json), независимая проверка на Cedar, реестр утверждений: каждое число воспроизводится командой</a:t>
                       </a:r>
                       <a:endParaRPr lang="en-US" sz="1300" dirty="0">
                         <a:latin typeface="Calibri" charset="0"/>

</xml_diff>

<commit_message>
docs: P0 Ваня — POSIX-only status, rebuild deck 15.10, line coverage
- RESPONSE/LIMITS/DEMO: import fcntl = Windows ImportError; status registry
  только Linux/Docker/WSL (не «flock uncovered»)
- SUBMISSION_DRIFT + slides: колода пересобрана 15.10.2026 из evidence (993)
- CHANGELOG #18: 95,8 % = line coverage из evidence.json
</commit_message>
<xml_diff>
--- a/submission/slides/Mandat_VTB.pptx
+++ b/submission/slides/Mandat_VTB.pptx
@@ -134,7 +134,7 @@
   <p:extLst>
     <p:ext uri="{521415D9-36F7-43E2-AB2F-B90AF26B5E84}">
       <p14:sectionLst xmlns:p14="http://schemas.microsoft.com/office/powerpoint/2010/main">
-        <p14:section name="Питч · 5 минут" id="{a9219409-316c-49ef-ba47-e716a756a317}">
+        <p14:section name="Питч · 5 минут" id="{f5813c45-1264-a1ef-b8f5-95890cb31b5b}">
           <p14:sldIdLst>
             <p14:sldId id="256"/>
             <p14:sldId id="257"/>
@@ -152,7 +152,7 @@
             <p14:sldId id="269"/>
           </p14:sldIdLst>
         </p14:section>
-        <p14:section name="Приложение для вопросов жюри" id="{2a89f822-9bc9-6891-0459-870cdbc324e8}">
+        <p14:section name="Приложение для вопросов жюри" id="{ce7bd8d7-9c2a-59a4-364f-877f447b8a6d}">
           <p14:sldIdLst>
             <p14:sldId id="270"/>
             <p14:sldId id="271"/>

</xml_diff>

<commit_message>
docs: post-merge #18 factcheck (993) + external audit response (#19)
* docs: post-merge #18 factcheck deltas + external audit response

- SUBMISSION_DRIFT: slides/evidence автотесты 993 (не 872)
- CHANGELOG: запись #18 (993 / 95,8 %)
- AUDIT-EXTERNAL-2026-10-15-RESPONSE: карта M-01…M-14 без завышений

* docs: nits Вани — LIMITS flock/replicas, DEMO AUDIT_MANDAT, RUN exit 2

- LIMITS: status lists single-node/flock, без multi-replica writers
- DEMO: M-01/M-02 → AUDIT_MANDAT M-01/M-02 (не путать с CLAIMS_REGISTRY)
- RUN: задокументирован exit code 2 для attest-verify

* docs: P0 Ваня — POSIX-only status, rebuild deck 15.10, line coverage

- RESPONSE/LIMITS/DEMO: import fcntl = Windows ImportError; status registry
  только Linux/Docker/WSL (не «flock uncovered»)
- SUBMISSION_DRIFT + slides: колода пересобрана 15.10.2026 из evidence (993)
- CHANGELOG #18: 95,8 % = line coverage из evidence.json

---------

Co-authored-by: KonkovDV <konkovdv@users.noreply.github.com>
</commit_message>
<xml_diff>
--- a/submission/slides/Mandat_VTB.pptx
+++ b/submission/slides/Mandat_VTB.pptx
@@ -134,7 +134,7 @@
   <p:extLst>
     <p:ext uri="{521415D9-36F7-43E2-AB2F-B90AF26B5E84}">
       <p14:sectionLst xmlns:p14="http://schemas.microsoft.com/office/powerpoint/2010/main">
-        <p14:section name="Питч · 5 минут" id="{a9219409-316c-49ef-ba47-e716a756a317}">
+        <p14:section name="Питч · 5 минут" id="{f5813c45-1264-a1ef-b8f5-95890cb31b5b}">
           <p14:sldIdLst>
             <p14:sldId id="256"/>
             <p14:sldId id="257"/>
@@ -152,7 +152,7 @@
             <p14:sldId id="269"/>
           </p14:sldIdLst>
         </p14:section>
-        <p14:section name="Приложение для вопросов жюри" id="{2a89f822-9bc9-6891-0459-870cdbc324e8}">
+        <p14:section name="Приложение для вопросов жюри" id="{ce7bd8d7-9c2a-59a4-364f-877f447b8a6d}">
           <p14:sldIdLst>
             <p14:sldId id="270"/>
             <p14:sldId id="271"/>

</xml_diff>

<commit_message>
fix(M-06): require HTTPS for LLM in pilot/prod
Loopback http (127.0.0.1/localhost/::1) only with
MANDAT_LLM_ALLOW_INSECURE_LOOPBACK=1. Evidence/docs/deck → 1000 tests.
</commit_message>
<xml_diff>
--- a/submission/slides/Mandat_VTB.pptx
+++ b/submission/slides/Mandat_VTB.pptx
@@ -134,7 +134,7 @@
   <p:extLst>
     <p:ext uri="{521415D9-36F7-43E2-AB2F-B90AF26B5E84}">
       <p14:sectionLst xmlns:p14="http://schemas.microsoft.com/office/powerpoint/2010/main">
-        <p14:section name="Питч · 5 минут" id="{f5813c45-1264-a1ef-b8f5-95890cb31b5b}">
+        <p14:section name="Питч · 5 минут" id="{53f84952-d4a6-e0f5-c745-1046f85e0ecb}">
           <p14:sldIdLst>
             <p14:sldId id="256"/>
             <p14:sldId id="257"/>
@@ -152,7 +152,7 @@
             <p14:sldId id="269"/>
           </p14:sldIdLst>
         </p14:section>
-        <p14:section name="Приложение для вопросов жюри" id="{ce7bd8d7-9c2a-59a4-364f-877f447b8a6d}">
+        <p14:section name="Приложение для вопросов жюри" id="{a4864a79-edce-468e-816a-75f280244ecb}">
           <p14:sldIdLst>
             <p14:sldId id="270"/>
             <p14:sldId id="271"/>
@@ -6183,7 +6183,7 @@
                   <a:schemeClr val="accent4"/>
                 </a:solidFill>
               </a:rPr>
-              <a:t>Источники: vtb.ru — «Комплект МЧД и КЭП» в «ВТБ Бизнес», 10.2026; репозиторий «Мандата» v0.3.0: 993 автотеста, evidence.json от 15.10.2026</a:t>
+              <a:t>Источники: vtb.ru — «Комплект МЧД и КЭП» в «ВТБ Бизнес», 10.2026; репозиторий «Мандата» v0.3.0: 1000 автотестов, evidence.json от 15.10.2026</a:t>
             </a:r>
             <a:endParaRPr lang="en-US" sz="1000" dirty="0"/>
           </a:p>
@@ -7046,7 +7046,7 @@
                   <a:schemeClr val="bg1"/>
                 </a:solidFill>
               </a:rPr>
-              <a:t>993 автотеста проходят, каждое число воспроизводится командой</a:t>
+              <a:t>1000 автотестов проходят, каждое число воспроизводится командой</a:t>
             </a:r>
             <a:endParaRPr lang="en-US" sz="1500" dirty="0"/>
           </a:p>
@@ -12430,7 +12430,7 @@
                           <a:ea typeface="Calibri" pitchFamily="34" charset="-122"/>
                           <a:cs typeface="Calibri" pitchFamily="34" charset="-120"/>
                         </a:rPr>
-                        <a:t>993 автотестов; evidence.json</a:t>
+                        <a:t>1000 автотестов; evidence.json</a:t>
                       </a:r>
                       <a:endParaRPr lang="en-US" sz="1400" dirty="0">
                         <a:latin typeface="Calibri" charset="0"/>
@@ -25390,7 +25390,7 @@
                           <a:ea typeface="Calibri" pitchFamily="34" charset="-122"/>
                           <a:cs typeface="Calibri" pitchFamily="34" charset="-120"/>
                         </a:rPr>
-                        <a:t>993 автотеста проходят (v0.3.0, evidence.json), независимая проверка на Cedar, реестр утверждений: каждое число воспроизводится командой</a:t>
+                        <a:t>1000 автотестов проходят (v0.3.0, evidence.json), независимая проверка на Cedar, реестр утверждений: каждое число воспроизводится командой</a:t>
                       </a:r>
                       <a:endParaRPr lang="en-US" sz="1300" dirty="0">
                         <a:latin typeface="Calibri" charset="0"/>

</xml_diff>

<commit_message>
fix(M-13): status list freshness by operation risk
status_max_age_for(risk); unknown→strictest; authorize requires seen
in protected; CLI --operation-risk; outage docs. Evidence→1013.
</commit_message>
<xml_diff>
--- a/submission/slides/Mandat_VTB.pptx
+++ b/submission/slides/Mandat_VTB.pptx
@@ -134,7 +134,7 @@
   <p:extLst>
     <p:ext uri="{521415D9-36F7-43E2-AB2F-B90AF26B5E84}">
       <p14:sectionLst xmlns:p14="http://schemas.microsoft.com/office/powerpoint/2010/main">
-        <p14:section name="Питч · 5 минут" id="{53f84952-d4a6-e0f5-c745-1046f85e0ecb}">
+        <p14:section name="Питч · 5 минут" id="{5674b779-a378-4a4d-66f2-f4d49f20a8ce}">
           <p14:sldIdLst>
             <p14:sldId id="256"/>
             <p14:sldId id="257"/>
@@ -152,7 +152,7 @@
             <p14:sldId id="269"/>
           </p14:sldIdLst>
         </p14:section>
-        <p14:section name="Приложение для вопросов жюри" id="{a4864a79-edce-468e-816a-75f280244ecb}">
+        <p14:section name="Приложение для вопросов жюри" id="{2557e5a9-74e6-1c1f-6b8a-a783ba2f5bff}">
           <p14:sldIdLst>
             <p14:sldId id="270"/>
             <p14:sldId id="271"/>
@@ -6183,7 +6183,7 @@
                   <a:schemeClr val="accent4"/>
                 </a:solidFill>
               </a:rPr>
-              <a:t>Источники: vtb.ru — «Комплект МЧД и КЭП» в «ВТБ Бизнес», 10.2026; репозиторий «Мандата» v0.3.0: 1000 автотестов, evidence.json от 15.10.2026</a:t>
+              <a:t>Источники: vtb.ru — «Комплект МЧД и КЭП» в «ВТБ Бизнес», 10.2026; репозиторий «Мандата» v0.3.0: 1013 автотестов, evidence.json от 15.10.2026</a:t>
             </a:r>
             <a:endParaRPr lang="en-US" sz="1000" dirty="0"/>
           </a:p>
@@ -7046,7 +7046,7 @@
                   <a:schemeClr val="bg1"/>
                 </a:solidFill>
               </a:rPr>
-              <a:t>1000 автотестов проходят, каждое число воспроизводится командой</a:t>
+              <a:t>1013 автотестов проходят, каждое число воспроизводится командой</a:t>
             </a:r>
             <a:endParaRPr lang="en-US" sz="1500" dirty="0"/>
           </a:p>
@@ -12430,7 +12430,7 @@
                           <a:ea typeface="Calibri" pitchFamily="34" charset="-122"/>
                           <a:cs typeface="Calibri" pitchFamily="34" charset="-120"/>
                         </a:rPr>
-                        <a:t>1000 автотестов; evidence.json</a:t>
+                        <a:t>1013 автотестов; evidence.json</a:t>
                       </a:r>
                       <a:endParaRPr lang="en-US" sz="1400" dirty="0">
                         <a:latin typeface="Calibri" charset="0"/>
@@ -25390,7 +25390,7 @@
                           <a:ea typeface="Calibri" pitchFamily="34" charset="-122"/>
                           <a:cs typeface="Calibri" pitchFamily="34" charset="-120"/>
                         </a:rPr>
-                        <a:t>1000 автотестов проходят (v0.3.0, evidence.json), независимая проверка на Cedar, реестр утверждений: каждое число воспроизводится командой</a:t>
+                        <a:t>1013 автотестов проходят (v0.3.0, evidence.json), независимая проверка на Cedar, реестр утверждений: каждое число воспроизводится командой</a:t>
                       </a:r>
                       <a:endParaRPr lang="en-US" sz="1300" dirty="0">
                         <a:latin typeface="Calibri" charset="0"/>

</xml_diff>

<commit_message>
fix(M-06): require HTTPS for LLM in pilot/prod (#21)
Loopback http (127.0.0.1/localhost/::1) only with
MANDAT_LLM_ALLOW_INSECURE_LOOPBACK=1. Evidence/docs/deck → 1000 tests.

Co-authored-by: KonkovDV <konkovdv@users.noreply.github.com>
</commit_message>
<xml_diff>
--- a/submission/slides/Mandat_VTB.pptx
+++ b/submission/slides/Mandat_VTB.pptx
@@ -134,7 +134,7 @@
   <p:extLst>
     <p:ext uri="{521415D9-36F7-43E2-AB2F-B90AF26B5E84}">
       <p14:sectionLst xmlns:p14="http://schemas.microsoft.com/office/powerpoint/2010/main">
-        <p14:section name="Питч · 5 минут" id="{f5813c45-1264-a1ef-b8f5-95890cb31b5b}">
+        <p14:section name="Питч · 5 минут" id="{53f84952-d4a6-e0f5-c745-1046f85e0ecb}">
           <p14:sldIdLst>
             <p14:sldId id="256"/>
             <p14:sldId id="257"/>
@@ -152,7 +152,7 @@
             <p14:sldId id="269"/>
           </p14:sldIdLst>
         </p14:section>
-        <p14:section name="Приложение для вопросов жюри" id="{ce7bd8d7-9c2a-59a4-364f-877f447b8a6d}">
+        <p14:section name="Приложение для вопросов жюри" id="{a4864a79-edce-468e-816a-75f280244ecb}">
           <p14:sldIdLst>
             <p14:sldId id="270"/>
             <p14:sldId id="271"/>
@@ -6183,7 +6183,7 @@
                   <a:schemeClr val="accent4"/>
                 </a:solidFill>
               </a:rPr>
-              <a:t>Источники: vtb.ru — «Комплект МЧД и КЭП» в «ВТБ Бизнес», 10.2026; репозиторий «Мандата» v0.3.0: 993 автотеста, evidence.json от 15.10.2026</a:t>
+              <a:t>Источники: vtb.ru — «Комплект МЧД и КЭП» в «ВТБ Бизнес», 10.2026; репозиторий «Мандата» v0.3.0: 1000 автотестов, evidence.json от 15.10.2026</a:t>
             </a:r>
             <a:endParaRPr lang="en-US" sz="1000" dirty="0"/>
           </a:p>
@@ -7046,7 +7046,7 @@
                   <a:schemeClr val="bg1"/>
                 </a:solidFill>
               </a:rPr>
-              <a:t>993 автотеста проходят, каждое число воспроизводится командой</a:t>
+              <a:t>1000 автотестов проходят, каждое число воспроизводится командой</a:t>
             </a:r>
             <a:endParaRPr lang="en-US" sz="1500" dirty="0"/>
           </a:p>
@@ -12430,7 +12430,7 @@
                           <a:ea typeface="Calibri" pitchFamily="34" charset="-122"/>
                           <a:cs typeface="Calibri" pitchFamily="34" charset="-120"/>
                         </a:rPr>
-                        <a:t>993 автотестов; evidence.json</a:t>
+                        <a:t>1000 автотестов; evidence.json</a:t>
                       </a:r>
                       <a:endParaRPr lang="en-US" sz="1400" dirty="0">
                         <a:latin typeface="Calibri" charset="0"/>
@@ -25390,7 +25390,7 @@
                           <a:ea typeface="Calibri" pitchFamily="34" charset="-122"/>
                           <a:cs typeface="Calibri" pitchFamily="34" charset="-120"/>
                         </a:rPr>
-                        <a:t>993 автотеста проходят (v0.3.0, evidence.json), независимая проверка на Cedar, реестр утверждений: каждое число воспроизводится командой</a:t>
+                        <a:t>1000 автотестов проходят (v0.3.0, evidence.json), независимая проверка на Cedar, реестр утверждений: каждое число воспроизводится командой</a:t>
                       </a:r>
                       <a:endParaRPr lang="en-US" sz="1300" dirty="0">
                         <a:latin typeface="Calibri" charset="0"/>

</xml_diff>

<commit_message>
fix(M-13): status freshness by risk + G1 min(global,risk) (#24)
* fix(M-13): status list freshness by operation risk

status_max_age_for(risk); unknown→strictest; authorize requires seen
in protected; CLI --operation-risk; outage docs. Evidence→1013.

* fix(M-13): G1 min(global, risk) for status max age

MANDAT_STATUS_MAX_AGE_DAYS is a ceiling, not a full override — payment
stays ~1h even if global=7. LIMITS: attest-verify ≠ authorize.

* chore: rebuild evidence after G1 (verify-source)

---------

Co-authored-by: KonkovDV <konkovdv@users.noreply.github.com>
</commit_message>
<xml_diff>
--- a/submission/slides/Mandat_VTB.pptx
+++ b/submission/slides/Mandat_VTB.pptx
@@ -134,7 +134,7 @@
   <p:extLst>
     <p:ext uri="{521415D9-36F7-43E2-AB2F-B90AF26B5E84}">
       <p14:sectionLst xmlns:p14="http://schemas.microsoft.com/office/powerpoint/2010/main">
-        <p14:section name="Питч · 5 минут" id="{53f84952-d4a6-e0f5-c745-1046f85e0ecb}">
+        <p14:section name="Питч · 5 минут" id="{5674b779-a378-4a4d-66f2-f4d49f20a8ce}">
           <p14:sldIdLst>
             <p14:sldId id="256"/>
             <p14:sldId id="257"/>
@@ -152,7 +152,7 @@
             <p14:sldId id="269"/>
           </p14:sldIdLst>
         </p14:section>
-        <p14:section name="Приложение для вопросов жюри" id="{a4864a79-edce-468e-816a-75f280244ecb}">
+        <p14:section name="Приложение для вопросов жюри" id="{2557e5a9-74e6-1c1f-6b8a-a783ba2f5bff}">
           <p14:sldIdLst>
             <p14:sldId id="270"/>
             <p14:sldId id="271"/>
@@ -6183,7 +6183,7 @@
                   <a:schemeClr val="accent4"/>
                 </a:solidFill>
               </a:rPr>
-              <a:t>Источники: vtb.ru — «Комплект МЧД и КЭП» в «ВТБ Бизнес», 10.2026; репозиторий «Мандата» v0.3.0: 1000 автотестов, evidence.json от 15.10.2026</a:t>
+              <a:t>Источники: vtb.ru — «Комплект МЧД и КЭП» в «ВТБ Бизнес», 10.2026; репозиторий «Мандата» v0.3.0: 1013 автотестов, evidence.json от 15.10.2026</a:t>
             </a:r>
             <a:endParaRPr lang="en-US" sz="1000" dirty="0"/>
           </a:p>
@@ -7046,7 +7046,7 @@
                   <a:schemeClr val="bg1"/>
                 </a:solidFill>
               </a:rPr>
-              <a:t>1000 автотестов проходят, каждое число воспроизводится командой</a:t>
+              <a:t>1013 автотестов проходят, каждое число воспроизводится командой</a:t>
             </a:r>
             <a:endParaRPr lang="en-US" sz="1500" dirty="0"/>
           </a:p>
@@ -12430,7 +12430,7 @@
                           <a:ea typeface="Calibri" pitchFamily="34" charset="-122"/>
                           <a:cs typeface="Calibri" pitchFamily="34" charset="-120"/>
                         </a:rPr>
-                        <a:t>1000 автотестов; evidence.json</a:t>
+                        <a:t>1013 автотестов; evidence.json</a:t>
                       </a:r>
                       <a:endParaRPr lang="en-US" sz="1400" dirty="0">
                         <a:latin typeface="Calibri" charset="0"/>
@@ -25390,7 +25390,7 @@
                           <a:ea typeface="Calibri" pitchFamily="34" charset="-122"/>
                           <a:cs typeface="Calibri" pitchFamily="34" charset="-120"/>
                         </a:rPr>
-                        <a:t>1000 автотестов проходят (v0.3.0, evidence.json), независимая проверка на Cedar, реестр утверждений: каждое число воспроизводится командой</a:t>
+                        <a:t>1013 автотестов проходят (v0.3.0, evidence.json), независимая проверка на Cedar, реестр утверждений: каждое число воспроизводится командой</a:t>
                       </a:r>
                       <a:endParaRPr lang="en-US" sz="1300" dirty="0">
                         <a:latin typeface="Calibri" charset="0"/>

</xml_diff>

<commit_message>
chore(evidence): rebuild deck for 1017 tests
pptx+pdf from evidence; lint_claims clean.
</commit_message>
<xml_diff>
--- a/submission/slides/Mandat_VTB.pptx
+++ b/submission/slides/Mandat_VTB.pptx
@@ -134,7 +134,7 @@
   <p:extLst>
     <p:ext uri="{521415D9-36F7-43E2-AB2F-B90AF26B5E84}">
       <p14:sectionLst xmlns:p14="http://schemas.microsoft.com/office/powerpoint/2010/main">
-        <p14:section name="Питч · 5 минут" id="{5674b779-a378-4a4d-66f2-f4d49f20a8ce}">
+        <p14:section name="Питч · 5 минут" id="{9d780934-b275-b381-c6c7-c7c5da043ce9}">
           <p14:sldIdLst>
             <p14:sldId id="256"/>
             <p14:sldId id="257"/>
@@ -152,7 +152,7 @@
             <p14:sldId id="269"/>
           </p14:sldIdLst>
         </p14:section>
-        <p14:section name="Приложение для вопросов жюри" id="{2557e5a9-74e6-1c1f-6b8a-a783ba2f5bff}">
+        <p14:section name="Приложение для вопросов жюри" id="{2fdc41bd-a6fc-1370-6260-2713234563aa}">
           <p14:sldIdLst>
             <p14:sldId id="270"/>
             <p14:sldId id="271"/>
@@ -6183,7 +6183,7 @@
                   <a:schemeClr val="accent4"/>
                 </a:solidFill>
               </a:rPr>
-              <a:t>Источники: vtb.ru — «Комплект МЧД и КЭП» в «ВТБ Бизнес», 10.2026; репозиторий «Мандата» v0.3.0: 1013 автотестов, evidence.json от 15.10.2026</a:t>
+              <a:t>Источники: vtb.ru — «Комплект МЧД и КЭП» в «ВТБ Бизнес», 10.2026; репозиторий «Мандата» v0.3.0: 1017 автотестов, evidence.json от 15.10.2026</a:t>
             </a:r>
             <a:endParaRPr lang="en-US" sz="1000" dirty="0"/>
           </a:p>
@@ -7046,7 +7046,7 @@
                   <a:schemeClr val="bg1"/>
                 </a:solidFill>
               </a:rPr>
-              <a:t>1013 автотестов проходят, каждое число воспроизводится командой</a:t>
+              <a:t>1017 автотестов проходят, каждое число воспроизводится командой</a:t>
             </a:r>
             <a:endParaRPr lang="en-US" sz="1500" dirty="0"/>
           </a:p>
@@ -12430,7 +12430,7 @@
                           <a:ea typeface="Calibri" pitchFamily="34" charset="-122"/>
                           <a:cs typeface="Calibri" pitchFamily="34" charset="-120"/>
                         </a:rPr>
-                        <a:t>1013 автотестов; evidence.json</a:t>
+                        <a:t>1017 автотестов; evidence.json</a:t>
                       </a:r>
                       <a:endParaRPr lang="en-US" sz="1400" dirty="0">
                         <a:latin typeface="Calibri" charset="0"/>
@@ -25390,7 +25390,7 @@
                           <a:ea typeface="Calibri" pitchFamily="34" charset="-122"/>
                           <a:cs typeface="Calibri" pitchFamily="34" charset="-120"/>
                         </a:rPr>
-                        <a:t>1013 автотестов проходят (v0.3.0, evidence.json), независимая проверка на Cedar, реестр утверждений: каждое число воспроизводится командой</a:t>
+                        <a:t>1017 автотестов проходят (v0.3.0, evidence.json), независимая проверка на Cedar, реестр утверждений: каждое число воспроизводится командой</a:t>
                       </a:r>
                       <a:endParaRPr lang="en-US" sz="1300" dirty="0">
                         <a:latin typeface="Calibri" charset="0"/>

</xml_diff>

<commit_message>
fix(M-03): pilot compose overlay, /readyz, readiness healthcheck, CI compose up --wait
</commit_message>
<xml_diff>
--- a/submission/slides/Mandat_VTB.pptx
+++ b/submission/slides/Mandat_VTB.pptx
@@ -134,7 +134,7 @@
   <p:extLst>
     <p:ext uri="{521415D9-36F7-43E2-AB2F-B90AF26B5E84}">
       <p14:sectionLst xmlns:p14="http://schemas.microsoft.com/office/powerpoint/2010/main">
-        <p14:section name="Питч · 5 минут" id="{9d780934-b275-b381-c6c7-c7c5da043ce9}">
+        <p14:section name="Питч · 5 минут" id="{545041aa-0720-7ce6-eae2-9dd706a76731}">
           <p14:sldIdLst>
             <p14:sldId id="256"/>
             <p14:sldId id="257"/>
@@ -152,7 +152,7 @@
             <p14:sldId id="269"/>
           </p14:sldIdLst>
         </p14:section>
-        <p14:section name="Приложение для вопросов жюри" id="{2fdc41bd-a6fc-1370-6260-2713234563aa}">
+        <p14:section name="Приложение для вопросов жюри" id="{498d4031-39dd-a765-5308-a722ac2428bb}">
           <p14:sldIdLst>
             <p14:sldId id="270"/>
             <p14:sldId id="271"/>
@@ -6183,7 +6183,7 @@
                   <a:schemeClr val="accent4"/>
                 </a:solidFill>
               </a:rPr>
-              <a:t>Источники: vtb.ru — «Комплект МЧД и КЭП» в «ВТБ Бизнес», 10.2026; репозиторий «Мандата» v0.3.0: 1017 автотестов, evidence.json от 15.10.2026</a:t>
+              <a:t>Источники: vtb.ru — «Комплект МЧД и КЭП» в «ВТБ Бизнес», 10.2026; репозиторий «Мандата» v0.3.0: 1028 автотестов, evidence.json от 15.10.2026</a:t>
             </a:r>
             <a:endParaRPr lang="en-US" sz="1000" dirty="0"/>
           </a:p>
@@ -7046,7 +7046,7 @@
                   <a:schemeClr val="bg1"/>
                 </a:solidFill>
               </a:rPr>
-              <a:t>1017 автотестов проходят, каждое число воспроизводится командой</a:t>
+              <a:t>1028 автотестов проходят, каждое число воспроизводится командой</a:t>
             </a:r>
             <a:endParaRPr lang="en-US" sz="1500" dirty="0"/>
           </a:p>
@@ -12430,7 +12430,7 @@
                           <a:ea typeface="Calibri" pitchFamily="34" charset="-122"/>
                           <a:cs typeface="Calibri" pitchFamily="34" charset="-120"/>
                         </a:rPr>
-                        <a:t>1017 автотестов; evidence.json</a:t>
+                        <a:t>1028 автотестов; evidence.json</a:t>
                       </a:r>
                       <a:endParaRPr lang="en-US" sz="1400" dirty="0">
                         <a:latin typeface="Calibri" charset="0"/>
@@ -25390,7 +25390,7 @@
                           <a:ea typeface="Calibri" pitchFamily="34" charset="-122"/>
                           <a:cs typeface="Calibri" pitchFamily="34" charset="-120"/>
                         </a:rPr>
-                        <a:t>1017 автотестов проходят (v0.3.0, evidence.json), независимая проверка на Cedar, реестр утверждений: каждое число воспроизводится командой</a:t>
+                        <a:t>1028 автотестов проходят (v0.3.0, evidence.json), независимая проверка на Cedar, реестр утверждений: каждое число воспроизводится командой</a:t>
                       </a:r>
                       <a:endParaRPr lang="en-US" sz="1300" dirty="0">
                         <a:latin typeface="Calibri" charset="0"/>

</xml_diff>

<commit_message>
fix(G-B): protected blank operation_risk = strictest; demo attest-verify prints no success before status
</commit_message>
<xml_diff>
--- a/submission/slides/Mandat_VTB.pptx
+++ b/submission/slides/Mandat_VTB.pptx
@@ -134,7 +134,7 @@
   <p:extLst>
     <p:ext uri="{521415D9-36F7-43E2-AB2F-B90AF26B5E84}">
       <p14:sectionLst xmlns:p14="http://schemas.microsoft.com/office/powerpoint/2010/main">
-        <p14:section name="Питч · 5 минут" id="{9d780934-b275-b381-c6c7-c7c5da043ce9}">
+        <p14:section name="Питч · 5 минут" id="{6bad9cb6-33b4-c080-6420-df99a9f1cd19}">
           <p14:sldIdLst>
             <p14:sldId id="256"/>
             <p14:sldId id="257"/>
@@ -152,7 +152,7 @@
             <p14:sldId id="269"/>
           </p14:sldIdLst>
         </p14:section>
-        <p14:section name="Приложение для вопросов жюри" id="{2fdc41bd-a6fc-1370-6260-2713234563aa}">
+        <p14:section name="Приложение для вопросов жюри" id="{f4038696-e2b8-d4d1-2579-932cc2e4e61d}">
           <p14:sldIdLst>
             <p14:sldId id="270"/>
             <p14:sldId id="271"/>
@@ -6183,7 +6183,7 @@
                   <a:schemeClr val="accent4"/>
                 </a:solidFill>
               </a:rPr>
-              <a:t>Источники: vtb.ru — «Комплект МЧД и КЭП» в «ВТБ Бизнес», 10.2026; репозиторий «Мандата» v0.3.0: 1017 автотестов, evidence.json от 15.10.2026</a:t>
+              <a:t>Источники: vtb.ru — «Комплект МЧД и КЭП» в «ВТБ Бизнес», 10.2026; репозиторий «Мандата» v0.3.0: 1041 автотест, evidence.json от 15.10.2026</a:t>
             </a:r>
             <a:endParaRPr lang="en-US" sz="1000" dirty="0"/>
           </a:p>
@@ -7046,7 +7046,7 @@
                   <a:schemeClr val="bg1"/>
                 </a:solidFill>
               </a:rPr>
-              <a:t>1017 автотестов проходят, каждое число воспроизводится командой</a:t>
+              <a:t>1041 автотест проходят, каждое число воспроизводится командой</a:t>
             </a:r>
             <a:endParaRPr lang="en-US" sz="1500" dirty="0"/>
           </a:p>
@@ -12430,7 +12430,7 @@
                           <a:ea typeface="Calibri" pitchFamily="34" charset="-122"/>
                           <a:cs typeface="Calibri" pitchFamily="34" charset="-120"/>
                         </a:rPr>
-                        <a:t>1017 автотестов; evidence.json</a:t>
+                        <a:t>1041 автотестов; evidence.json</a:t>
                       </a:r>
                       <a:endParaRPr lang="en-US" sz="1400" dirty="0">
                         <a:latin typeface="Calibri" charset="0"/>
@@ -25390,7 +25390,7 @@
                           <a:ea typeface="Calibri" pitchFamily="34" charset="-122"/>
                           <a:cs typeface="Calibri" pitchFamily="34" charset="-120"/>
                         </a:rPr>
-                        <a:t>1017 автотестов проходят (v0.3.0, evidence.json), независимая проверка на Cedar, реестр утверждений: каждое число воспроизводится командой</a:t>
+                        <a:t>1041 автотест проходят (v0.3.0, evidence.json), независимая проверка на Cedar, реестр утверждений: каждое число воспроизводится командой</a:t>
                       </a:r>
                       <a:endParaRPr lang="en-US" sz="1300" dirty="0">
                         <a:latin typeface="Calibri" charset="0"/>

</xml_diff>

<commit_message>
wip(M-10): two-phase write (pre-finalize)
</commit_message>
<xml_diff>
--- a/submission/slides/Mandat_VTB.pptx
+++ b/submission/slides/Mandat_VTB.pptx
@@ -134,7 +134,7 @@
   <p:extLst>
     <p:ext uri="{521415D9-36F7-43E2-AB2F-B90AF26B5E84}">
       <p14:sectionLst xmlns:p14="http://schemas.microsoft.com/office/powerpoint/2010/main">
-        <p14:section name="Питч · 5 минут" id="{9d780934-b275-b381-c6c7-c7c5da043ce9}">
+        <p14:section name="Питч · 5 минут" id="{f585a702-c565-2666-f758-4276dcef3cf4}">
           <p14:sldIdLst>
             <p14:sldId id="256"/>
             <p14:sldId id="257"/>
@@ -152,7 +152,7 @@
             <p14:sldId id="269"/>
           </p14:sldIdLst>
         </p14:section>
-        <p14:section name="Приложение для вопросов жюри" id="{2fdc41bd-a6fc-1370-6260-2713234563aa}">
+        <p14:section name="Приложение для вопросов жюри" id="{594c04b9-7859-769d-6a4b-888bb57d7350}">
           <p14:sldIdLst>
             <p14:sldId id="270"/>
             <p14:sldId id="271"/>
@@ -6183,7 +6183,7 @@
                   <a:schemeClr val="accent4"/>
                 </a:solidFill>
               </a:rPr>
-              <a:t>Источники: vtb.ru — «Комплект МЧД и КЭП» в «ВТБ Бизнес», 10.2026; репозиторий «Мандата» v0.3.0: 1017 автотестов, evidence.json от 15.10.2026</a:t>
+              <a:t>Источники: vtb.ru — «Комплект МЧД и КЭП» в «ВТБ Бизнес», 10.2026; репозиторий «Мандата» v0.3.0: 1070 автотестов, evidence.json от 15.10.2026</a:t>
             </a:r>
             <a:endParaRPr lang="en-US" sz="1000" dirty="0"/>
           </a:p>
@@ -7046,7 +7046,7 @@
                   <a:schemeClr val="bg1"/>
                 </a:solidFill>
               </a:rPr>
-              <a:t>1017 автотестов проходят, каждое число воспроизводится командой</a:t>
+              <a:t>1070 автотестов проходят, каждое число воспроизводится командой</a:t>
             </a:r>
             <a:endParaRPr lang="en-US" sz="1500" dirty="0"/>
           </a:p>
@@ -12430,7 +12430,7 @@
                           <a:ea typeface="Calibri" pitchFamily="34" charset="-122"/>
                           <a:cs typeface="Calibri" pitchFamily="34" charset="-120"/>
                         </a:rPr>
-                        <a:t>1017 автотестов; evidence.json</a:t>
+                        <a:t>1070 автотестов; evidence.json</a:t>
                       </a:r>
                       <a:endParaRPr lang="en-US" sz="1400" dirty="0">
                         <a:latin typeface="Calibri" charset="0"/>
@@ -25390,7 +25390,7 @@
                           <a:ea typeface="Calibri" pitchFamily="34" charset="-122"/>
                           <a:cs typeface="Calibri" pitchFamily="34" charset="-120"/>
                         </a:rPr>
-                        <a:t>1017 автотестов проходят (v0.3.0, evidence.json), независимая проверка на Cedar, реестр утверждений: каждое число воспроизводится командой</a:t>
+                        <a:t>1070 автотестов проходят (v0.3.0, evidence.json), независимая проверка на Cedar, реестр утверждений: каждое число воспроизводится командой</a:t>
                       </a:r>
                       <a:endParaRPr lang="en-US" sz="1300" dirty="0">
                         <a:latin typeface="Calibri" charset="0"/>

</xml_diff>

<commit_message>
test/docs(G-B): unknown env, seen_file on refusal, exact exit codes; breaking-change notes; handoff
</commit_message>
<xml_diff>
--- a/submission/slides/Mandat_VTB.pptx
+++ b/submission/slides/Mandat_VTB.pptx
@@ -134,7 +134,7 @@
   <p:extLst>
     <p:ext uri="{521415D9-36F7-43E2-AB2F-B90AF26B5E84}">
       <p14:sectionLst xmlns:p14="http://schemas.microsoft.com/office/powerpoint/2010/main">
-        <p14:section name="Питч · 5 минут" id="{6bad9cb6-33b4-c080-6420-df99a9f1cd19}">
+        <p14:section name="Питч · 5 минут" id="{ffd5a99d-0788-4776-1727-360cefe60a97}">
           <p14:sldIdLst>
             <p14:sldId id="256"/>
             <p14:sldId id="257"/>
@@ -152,7 +152,7 @@
             <p14:sldId id="269"/>
           </p14:sldIdLst>
         </p14:section>
-        <p14:section name="Приложение для вопросов жюри" id="{f4038696-e2b8-d4d1-2579-932cc2e4e61d}">
+        <p14:section name="Приложение для вопросов жюри" id="{e2f3cab9-1a54-b22a-856a-3c1d52c72cbe}">
           <p14:sldIdLst>
             <p14:sldId id="270"/>
             <p14:sldId id="271"/>
@@ -6183,7 +6183,7 @@
                   <a:schemeClr val="accent4"/>
                 </a:solidFill>
               </a:rPr>
-              <a:t>Источники: vtb.ru — «Комплект МЧД и КЭП» в «ВТБ Бизнес», 10.2026; репозиторий «Мандата» v0.3.0: 1041 автотест, evidence.json от 15.10.2026</a:t>
+              <a:t>Источники: vtb.ru — «Комплект МЧД и КЭП» в «ВТБ Бизнес», 10.2026; репозиторий «Мандата» v0.3.0: 1046 автотестов, evidence.json от 15.10.2026</a:t>
             </a:r>
             <a:endParaRPr lang="en-US" sz="1000" dirty="0"/>
           </a:p>
@@ -7046,7 +7046,7 @@
                   <a:schemeClr val="bg1"/>
                 </a:solidFill>
               </a:rPr>
-              <a:t>1041 автотест проходят, каждое число воспроизводится командой</a:t>
+              <a:t>1046 автотестов проходят, каждое число воспроизводится командой</a:t>
             </a:r>
             <a:endParaRPr lang="en-US" sz="1500" dirty="0"/>
           </a:p>
@@ -12430,7 +12430,7 @@
                           <a:ea typeface="Calibri" pitchFamily="34" charset="-122"/>
                           <a:cs typeface="Calibri" pitchFamily="34" charset="-120"/>
                         </a:rPr>
-                        <a:t>1041 автотестов; evidence.json</a:t>
+                        <a:t>1046 автотестов; evidence.json</a:t>
                       </a:r>
                       <a:endParaRPr lang="en-US" sz="1400" dirty="0">
                         <a:latin typeface="Calibri" charset="0"/>
@@ -25390,7 +25390,7 @@
                           <a:ea typeface="Calibri" pitchFamily="34" charset="-122"/>
                           <a:cs typeface="Calibri" pitchFamily="34" charset="-120"/>
                         </a:rPr>
-                        <a:t>1041 автотест проходят (v0.3.0, evidence.json), независимая проверка на Cedar, реестр утверждений: каждое число воспроизводится командой</a:t>
+                        <a:t>1046 автотестов проходят (v0.3.0, evidence.json), независимая проверка на Cedar, реестр утверждений: каждое число воспроизводится командой</a:t>
                       </a:r>
                       <a:endParaRPr lang="en-US" sz="1300" dirty="0">
                         <a:latin typeface="Calibri" charset="0"/>

</xml_diff>

<commit_message>
fix(G-B): blank operation_risk is strictest in pilot/prod + demo revoked print bug (#28)
* fix(G-B): protected blank operation_risk = strictest; demo attest-verify prints no success before status

* test/docs(G-B): unknown env, seen_file on refusal, exact exit codes; breaking-change notes; handoff
</commit_message>
<xml_diff>
--- a/submission/slides/Mandat_VTB.pptx
+++ b/submission/slides/Mandat_VTB.pptx
@@ -134,7 +134,7 @@
   <p:extLst>
     <p:ext uri="{521415D9-36F7-43E2-AB2F-B90AF26B5E84}">
       <p14:sectionLst xmlns:p14="http://schemas.microsoft.com/office/powerpoint/2010/main">
-        <p14:section name="Питч · 5 минут" id="{9d780934-b275-b381-c6c7-c7c5da043ce9}">
+        <p14:section name="Питч · 5 минут" id="{ffd5a99d-0788-4776-1727-360cefe60a97}">
           <p14:sldIdLst>
             <p14:sldId id="256"/>
             <p14:sldId id="257"/>
@@ -152,7 +152,7 @@
             <p14:sldId id="269"/>
           </p14:sldIdLst>
         </p14:section>
-        <p14:section name="Приложение для вопросов жюри" id="{2fdc41bd-a6fc-1370-6260-2713234563aa}">
+        <p14:section name="Приложение для вопросов жюри" id="{e2f3cab9-1a54-b22a-856a-3c1d52c72cbe}">
           <p14:sldIdLst>
             <p14:sldId id="270"/>
             <p14:sldId id="271"/>
@@ -6183,7 +6183,7 @@
                   <a:schemeClr val="accent4"/>
                 </a:solidFill>
               </a:rPr>
-              <a:t>Источники: vtb.ru — «Комплект МЧД и КЭП» в «ВТБ Бизнес», 10.2026; репозиторий «Мандата» v0.3.0: 1017 автотестов, evidence.json от 15.10.2026</a:t>
+              <a:t>Источники: vtb.ru — «Комплект МЧД и КЭП» в «ВТБ Бизнес», 10.2026; репозиторий «Мандата» v0.3.0: 1046 автотестов, evidence.json от 15.10.2026</a:t>
             </a:r>
             <a:endParaRPr lang="en-US" sz="1000" dirty="0"/>
           </a:p>
@@ -7046,7 +7046,7 @@
                   <a:schemeClr val="bg1"/>
                 </a:solidFill>
               </a:rPr>
-              <a:t>1017 автотестов проходят, каждое число воспроизводится командой</a:t>
+              <a:t>1046 автотестов проходят, каждое число воспроизводится командой</a:t>
             </a:r>
             <a:endParaRPr lang="en-US" sz="1500" dirty="0"/>
           </a:p>
@@ -12430,7 +12430,7 @@
                           <a:ea typeface="Calibri" pitchFamily="34" charset="-122"/>
                           <a:cs typeface="Calibri" pitchFamily="34" charset="-120"/>
                         </a:rPr>
-                        <a:t>1017 автотестов; evidence.json</a:t>
+                        <a:t>1046 автотестов; evidence.json</a:t>
                       </a:r>
                       <a:endParaRPr lang="en-US" sz="1400" dirty="0">
                         <a:latin typeface="Calibri" charset="0"/>
@@ -25390,7 +25390,7 @@
                           <a:ea typeface="Calibri" pitchFamily="34" charset="-122"/>
                           <a:cs typeface="Calibri" pitchFamily="34" charset="-120"/>
                         </a:rPr>
-                        <a:t>1017 автотестов проходят (v0.3.0, evidence.json), независимая проверка на Cedar, реестр утверждений: каждое число воспроизводится командой</a:t>
+                        <a:t>1046 автотестов проходят (v0.3.0, evidence.json), независимая проверка на Cedar, реестр утверждений: каждое число воспроизводится командой</a:t>
                       </a:r>
                       <a:endParaRPr lang="en-US" sz="1300" dirty="0">
                         <a:latin typeface="Calibri" charset="0"/>

</xml_diff>

<commit_message>
fix(M-10): finalize evidence/deck, drop stray soffice files
</commit_message>
<xml_diff>
--- a/submission/slides/Mandat_VTB.pptx
+++ b/submission/slides/Mandat_VTB.pptx
@@ -134,7 +134,7 @@
   <p:extLst>
     <p:ext uri="{521415D9-36F7-43E2-AB2F-B90AF26B5E84}">
       <p14:sectionLst xmlns:p14="http://schemas.microsoft.com/office/powerpoint/2010/main">
-        <p14:section name="Питч · 5 минут" id="{f585a702-c565-2666-f758-4276dcef3cf4}">
+        <p14:section name="Питч · 5 минут" id="{02fe680b-f766-bdea-d2e2-156163dec357}">
           <p14:sldIdLst>
             <p14:sldId id="256"/>
             <p14:sldId id="257"/>
@@ -152,7 +152,7 @@
             <p14:sldId id="269"/>
           </p14:sldIdLst>
         </p14:section>
-        <p14:section name="Приложение для вопросов жюри" id="{594c04b9-7859-769d-6a4b-888bb57d7350}">
+        <p14:section name="Приложение для вопросов жюри" id="{f2683107-17d1-7a35-9d04-002fb970f2fa}">
           <p14:sldIdLst>
             <p14:sldId id="270"/>
             <p14:sldId id="271"/>

</xml_diff>

<commit_message>
fix(M-12): review fixes — inode+hash reload, TTL ceiling, CLI bounds, tests, docs
</commit_message>
<xml_diff>
--- a/submission/slides/Mandat_VTB.pptx
+++ b/submission/slides/Mandat_VTB.pptx
@@ -134,7 +134,7 @@
   <p:extLst>
     <p:ext uri="{521415D9-36F7-43E2-AB2F-B90AF26B5E84}">
       <p14:sectionLst xmlns:p14="http://schemas.microsoft.com/office/powerpoint/2010/main">
-        <p14:section name="Питч · 5 минут" id="{ffd5a99d-0788-4776-1727-360cefe60a97}">
+        <p14:section name="Питч · 5 минут" id="{5fe5125d-4a45-e0f0-7d3f-8be70f8fc870}">
           <p14:sldIdLst>
             <p14:sldId id="256"/>
             <p14:sldId id="257"/>
@@ -152,7 +152,7 @@
             <p14:sldId id="269"/>
           </p14:sldIdLst>
         </p14:section>
-        <p14:section name="Приложение для вопросов жюри" id="{e2f3cab9-1a54-b22a-856a-3c1d52c72cbe}">
+        <p14:section name="Приложение для вопросов жюри" id="{6e7c9e75-98d4-6245-fa7b-35b90c9bc87e}">
           <p14:sldIdLst>
             <p14:sldId id="270"/>
             <p14:sldId id="271"/>
@@ -6183,7 +6183,7 @@
                   <a:schemeClr val="accent4"/>
                 </a:solidFill>
               </a:rPr>
-              <a:t>Источники: vtb.ru — «Комплект МЧД и КЭП» в «ВТБ Бизнес», 10.2026; репозиторий «Мандата» v0.3.0: 1046 автотестов, evidence.json от 15.10.2026</a:t>
+              <a:t>Источники: vtb.ru — «Комплект МЧД и КЭП» в «ВТБ Бизнес», 10.2026; репозиторий «Мандата» v0.3.0: 1091 автотест, evidence.json от 15.10.2026</a:t>
             </a:r>
             <a:endParaRPr lang="en-US" sz="1000" dirty="0"/>
           </a:p>
@@ -7046,7 +7046,7 @@
                   <a:schemeClr val="bg1"/>
                 </a:solidFill>
               </a:rPr>
-              <a:t>1046 автотестов проходят, каждое число воспроизводится командой</a:t>
+              <a:t>1091 автотест проходят, каждое число воспроизводится командой</a:t>
             </a:r>
             <a:endParaRPr lang="en-US" sz="1500" dirty="0"/>
           </a:p>
@@ -12430,7 +12430,7 @@
                           <a:ea typeface="Calibri" pitchFamily="34" charset="-122"/>
                           <a:cs typeface="Calibri" pitchFamily="34" charset="-120"/>
                         </a:rPr>
-                        <a:t>1046 автотестов; evidence.json</a:t>
+                        <a:t>1091 автотестов; evidence.json</a:t>
                       </a:r>
                       <a:endParaRPr lang="en-US" sz="1400" dirty="0">
                         <a:latin typeface="Calibri" charset="0"/>
@@ -25390,7 +25390,7 @@
                           <a:ea typeface="Calibri" pitchFamily="34" charset="-122"/>
                           <a:cs typeface="Calibri" pitchFamily="34" charset="-120"/>
                         </a:rPr>
-                        <a:t>1046 автотестов проходят (v0.3.0, evidence.json), независимая проверка на Cedar, реестр утверждений: каждое число воспроизводится командой</a:t>
+                        <a:t>1091 автотест проходят (v0.3.0, evidence.json), независимая проверка на Cedar, реестр утверждений: каждое число воспроизводится командой</a:t>
                       </a:r>
                       <a:endParaRPr lang="en-US" sz="1300" dirty="0">
                         <a:latin typeface="Calibri" charset="0"/>

</xml_diff>

<commit_message>
fix(M-12): API token lifecycle: expires_at / revoked, revocation without restart (#29)
</commit_message>
<xml_diff>
--- a/submission/slides/Mandat_VTB.pptx
+++ b/submission/slides/Mandat_VTB.pptx
@@ -134,7 +134,7 @@
   <p:extLst>
     <p:ext uri="{521415D9-36F7-43E2-AB2F-B90AF26B5E84}">
       <p14:sectionLst xmlns:p14="http://schemas.microsoft.com/office/powerpoint/2010/main">
-        <p14:section name="Питч · 5 минут" id="{ffd5a99d-0788-4776-1727-360cefe60a97}">
+        <p14:section name="Питч · 5 минут" id="{5fe5125d-4a45-e0f0-7d3f-8be70f8fc870}">
           <p14:sldIdLst>
             <p14:sldId id="256"/>
             <p14:sldId id="257"/>
@@ -152,7 +152,7 @@
             <p14:sldId id="269"/>
           </p14:sldIdLst>
         </p14:section>
-        <p14:section name="Приложение для вопросов жюри" id="{e2f3cab9-1a54-b22a-856a-3c1d52c72cbe}">
+        <p14:section name="Приложение для вопросов жюри" id="{6e7c9e75-98d4-6245-fa7b-35b90c9bc87e}">
           <p14:sldIdLst>
             <p14:sldId id="270"/>
             <p14:sldId id="271"/>
@@ -6183,7 +6183,7 @@
                   <a:schemeClr val="accent4"/>
                 </a:solidFill>
               </a:rPr>
-              <a:t>Источники: vtb.ru — «Комплект МЧД и КЭП» в «ВТБ Бизнес», 10.2026; репозиторий «Мандата» v0.3.0: 1046 автотестов, evidence.json от 15.10.2026</a:t>
+              <a:t>Источники: vtb.ru — «Комплект МЧД и КЭП» в «ВТБ Бизнес», 10.2026; репозиторий «Мандата» v0.3.0: 1091 автотест, evidence.json от 15.10.2026</a:t>
             </a:r>
             <a:endParaRPr lang="en-US" sz="1000" dirty="0"/>
           </a:p>
@@ -7046,7 +7046,7 @@
                   <a:schemeClr val="bg1"/>
                 </a:solidFill>
               </a:rPr>
-              <a:t>1046 автотестов проходят, каждое число воспроизводится командой</a:t>
+              <a:t>1091 автотест проходят, каждое число воспроизводится командой</a:t>
             </a:r>
             <a:endParaRPr lang="en-US" sz="1500" dirty="0"/>
           </a:p>
@@ -12430,7 +12430,7 @@
                           <a:ea typeface="Calibri" pitchFamily="34" charset="-122"/>
                           <a:cs typeface="Calibri" pitchFamily="34" charset="-120"/>
                         </a:rPr>
-                        <a:t>1046 автотестов; evidence.json</a:t>
+                        <a:t>1091 автотестов; evidence.json</a:t>
                       </a:r>
                       <a:endParaRPr lang="en-US" sz="1400" dirty="0">
                         <a:latin typeface="Calibri" charset="0"/>
@@ -25390,7 +25390,7 @@
                           <a:ea typeface="Calibri" pitchFamily="34" charset="-122"/>
                           <a:cs typeface="Calibri" pitchFamily="34" charset="-120"/>
                         </a:rPr>
-                        <a:t>1046 автотестов проходят (v0.3.0, evidence.json), независимая проверка на Cedar, реестр утверждений: каждое число воспроизводится командой</a:t>
+                        <a:t>1091 автотест проходят (v0.3.0, evidence.json), независимая проверка на Cedar, реестр утверждений: каждое число воспроизводится командой</a:t>
                       </a:r>
                       <a:endParaRPr lang="en-US" sz="1300" dirty="0">
                         <a:latin typeface="Calibri" charset="0"/>

</xml_diff>

<commit_message>
fix(M-10): two-phase case write (stage → journal → commit), reconcile, Idempotency-Key, fencing (#30)
</commit_message>
<xml_diff>
--- a/submission/slides/Mandat_VTB.pptx
+++ b/submission/slides/Mandat_VTB.pptx
@@ -134,7 +134,7 @@
   <p:extLst>
     <p:ext uri="{521415D9-36F7-43E2-AB2F-B90AF26B5E84}">
       <p14:sectionLst xmlns:p14="http://schemas.microsoft.com/office/powerpoint/2010/main">
-        <p14:section name="Питч · 5 минут" id="{5fe5125d-4a45-e0f0-7d3f-8be70f8fc870}">
+        <p14:section name="Питч · 5 минут" id="{a7ef49d5-3875-3727-22b9-4387151783b8}">
           <p14:sldIdLst>
             <p14:sldId id="256"/>
             <p14:sldId id="257"/>
@@ -152,7 +152,7 @@
             <p14:sldId id="269"/>
           </p14:sldIdLst>
         </p14:section>
-        <p14:section name="Приложение для вопросов жюри" id="{6e7c9e75-98d4-6245-fa7b-35b90c9bc87e}">
+        <p14:section name="Приложение для вопросов жюри" id="{06907f38-e4ba-44b6-1f5a-c25425ad99e2}">
           <p14:sldIdLst>
             <p14:sldId id="270"/>
             <p14:sldId id="271"/>
@@ -6183,7 +6183,7 @@
                   <a:schemeClr val="accent4"/>
                 </a:solidFill>
               </a:rPr>
-              <a:t>Источники: vtb.ru — «Комплект МЧД и КЭП» в «ВТБ Бизнес», 10.2026; репозиторий «Мандата» v0.3.0: 1091 автотест, evidence.json от 15.10.2026</a:t>
+              <a:t>Источники: vtb.ru — «Комплект МЧД и КЭП» в «ВТБ Бизнес», 10.2026; репозиторий «Мандата» v0.3.0: 1144 автотеста, evidence.json от 15.10.2026</a:t>
             </a:r>
             <a:endParaRPr lang="en-US" sz="1000" dirty="0"/>
           </a:p>
@@ -7046,7 +7046,7 @@
                   <a:schemeClr val="bg1"/>
                 </a:solidFill>
               </a:rPr>
-              <a:t>1091 автотест проходят, каждое число воспроизводится командой</a:t>
+              <a:t>1144 автотеста проходят, каждое число воспроизводится командой</a:t>
             </a:r>
             <a:endParaRPr lang="en-US" sz="1500" dirty="0"/>
           </a:p>
@@ -12430,7 +12430,7 @@
                           <a:ea typeface="Calibri" pitchFamily="34" charset="-122"/>
                           <a:cs typeface="Calibri" pitchFamily="34" charset="-120"/>
                         </a:rPr>
-                        <a:t>1091 автотестов; evidence.json</a:t>
+                        <a:t>1144 автотестов; evidence.json</a:t>
                       </a:r>
                       <a:endParaRPr lang="en-US" sz="1400" dirty="0">
                         <a:latin typeface="Calibri" charset="0"/>
@@ -25390,7 +25390,7 @@
                           <a:ea typeface="Calibri" pitchFamily="34" charset="-122"/>
                           <a:cs typeface="Calibri" pitchFamily="34" charset="-120"/>
                         </a:rPr>
-                        <a:t>1091 автотест проходят (v0.3.0, evidence.json), независимая проверка на Cedar, реестр утверждений: каждое число воспроизводится командой</a:t>
+                        <a:t>1144 автотеста проходят (v0.3.0, evidence.json), независимая проверка на Cedar, реестр утверждений: каждое число воспроизводится командой</a:t>
                       </a:r>
                       <a:endParaRPr lang="en-US" sz="1300" dirty="0">
                         <a:latin typeface="Calibri" charset="0"/>

</xml_diff>

<commit_message>
test(M-14): targeted mutation tests for attestation and status_list
</commit_message>
<xml_diff>
--- a/submission/slides/Mandat_VTB.pptx
+++ b/submission/slides/Mandat_VTB.pptx
@@ -134,7 +134,7 @@
   <p:extLst>
     <p:ext uri="{521415D9-36F7-43E2-AB2F-B90AF26B5E84}">
       <p14:sectionLst xmlns:p14="http://schemas.microsoft.com/office/powerpoint/2010/main">
-        <p14:section name="Питч · 5 минут" id="{a7ef49d5-3875-3727-22b9-4387151783b8}">
+        <p14:section name="Питч · 5 минут" id="{098ca3ff-248d-e2b7-ef77-b8108a82c598}">
           <p14:sldIdLst>
             <p14:sldId id="256"/>
             <p14:sldId id="257"/>
@@ -152,7 +152,7 @@
             <p14:sldId id="269"/>
           </p14:sldIdLst>
         </p14:section>
-        <p14:section name="Приложение для вопросов жюри" id="{06907f38-e4ba-44b6-1f5a-c25425ad99e2}">
+        <p14:section name="Приложение для вопросов жюри" id="{21a4a41a-9323-ea34-e52c-574b792b1aca}">
           <p14:sldIdLst>
             <p14:sldId id="270"/>
             <p14:sldId id="271"/>
@@ -6183,7 +6183,7 @@
                   <a:schemeClr val="accent4"/>
                 </a:solidFill>
               </a:rPr>
-              <a:t>Источники: vtb.ru — «Комплект МЧД и КЭП» в «ВТБ Бизнес», 10.2026; репозиторий «Мандата» v0.3.0: 1144 автотеста, evidence.json от 15.10.2026</a:t>
+              <a:t>Источники: vtb.ru — «Комплект МЧД и КЭП» в «ВТБ Бизнес», 10.2026; репозиторий «Мандата» v0.3.0: 1161 автотест, evidence.json от 15.10.2026</a:t>
             </a:r>
             <a:endParaRPr lang="en-US" sz="1000" dirty="0"/>
           </a:p>
@@ -7046,7 +7046,7 @@
                   <a:schemeClr val="bg1"/>
                 </a:solidFill>
               </a:rPr>
-              <a:t>1144 автотеста проходят, каждое число воспроизводится командой</a:t>
+              <a:t>1161 автотест проходят, каждое число воспроизводится командой</a:t>
             </a:r>
             <a:endParaRPr lang="en-US" sz="1500" dirty="0"/>
           </a:p>
@@ -12430,7 +12430,7 @@
                           <a:ea typeface="Calibri" pitchFamily="34" charset="-122"/>
                           <a:cs typeface="Calibri" pitchFamily="34" charset="-120"/>
                         </a:rPr>
-                        <a:t>1144 автотестов; evidence.json</a:t>
+                        <a:t>1161 автотестов; evidence.json</a:t>
                       </a:r>
                       <a:endParaRPr lang="en-US" sz="1400" dirty="0">
                         <a:latin typeface="Calibri" charset="0"/>
@@ -25390,7 +25390,7 @@
                           <a:ea typeface="Calibri" pitchFamily="34" charset="-122"/>
                           <a:cs typeface="Calibri" pitchFamily="34" charset="-120"/>
                         </a:rPr>
-                        <a:t>1144 автотеста проходят (v0.3.0, evidence.json), независимая проверка на Cedar, реестр утверждений: каждое число воспроизводится командой</a:t>
+                        <a:t>1161 автотест проходят (v0.3.0, evidence.json), независимая проверка на Cedar, реестр утверждений: каждое число воспроизводится командой</a:t>
                       </a:r>
                       <a:endParaRPr lang="en-US" sz="1300" dirty="0">
                         <a:latin typeface="Calibri" charset="0"/>

</xml_diff>

<commit_message>
fix(M-03): pilot compose overlay + /readyz + CI compose up --wait
* fix(M-03): pilot compose overlay, /readyz, readiness healthcheck, CI compose up --wait

* chore(evidence): rebuild after new files tracked

* chore(M-03): rebuild evidence from committed sources

---------

Co-authored-by: Mandat <noreply@github.com>
</commit_message>
<xml_diff>
--- a/submission/slides/Mandat_VTB.pptx
+++ b/submission/slides/Mandat_VTB.pptx
@@ -134,7 +134,7 @@
   <p:extLst>
     <p:ext uri="{521415D9-36F7-43E2-AB2F-B90AF26B5E84}">
       <p14:sectionLst xmlns:p14="http://schemas.microsoft.com/office/powerpoint/2010/main">
-        <p14:section name="Питч · 5 минут" id="{a7ef49d5-3875-3727-22b9-4387151783b8}">
+        <p14:section name="Питч · 5 минут" id="{bb995f38-90ec-33dc-463c-26761da12218}">
           <p14:sldIdLst>
             <p14:sldId id="256"/>
             <p14:sldId id="257"/>
@@ -152,7 +152,7 @@
             <p14:sldId id="269"/>
           </p14:sldIdLst>
         </p14:section>
-        <p14:section name="Приложение для вопросов жюри" id="{06907f38-e4ba-44b6-1f5a-c25425ad99e2}">
+        <p14:section name="Приложение для вопросов жюри" id="{afb5a857-fb11-677c-28c4-d3975fd3c326}">
           <p14:sldIdLst>
             <p14:sldId id="270"/>
             <p14:sldId id="271"/>
@@ -6183,7 +6183,7 @@
                   <a:schemeClr val="accent4"/>
                 </a:solidFill>
               </a:rPr>
-              <a:t>Источники: vtb.ru — «Комплект МЧД и КЭП» в «ВТБ Бизнес», 10.2026; репозиторий «Мандата» v0.3.0: 1144 автотеста, evidence.json от 15.10.2026</a:t>
+              <a:t>Источники: vtb.ru — «Комплект МЧД и КЭП» в «ВТБ Бизнес», 10.2026; репозиторий «Мандата» v0.3.0: 1155 автотестов, evidence.json от 15.10.2026</a:t>
             </a:r>
             <a:endParaRPr lang="en-US" sz="1000" dirty="0"/>
           </a:p>
@@ -7046,7 +7046,7 @@
                   <a:schemeClr val="bg1"/>
                 </a:solidFill>
               </a:rPr>
-              <a:t>1144 автотеста проходят, каждое число воспроизводится командой</a:t>
+              <a:t>1155 автотестов проходят, каждое число воспроизводится командой</a:t>
             </a:r>
             <a:endParaRPr lang="en-US" sz="1500" dirty="0"/>
           </a:p>
@@ -12430,7 +12430,7 @@
                           <a:ea typeface="Calibri" pitchFamily="34" charset="-122"/>
                           <a:cs typeface="Calibri" pitchFamily="34" charset="-120"/>
                         </a:rPr>
-                        <a:t>1144 автотестов; evidence.json</a:t>
+                        <a:t>1155 автотестов; evidence.json</a:t>
                       </a:r>
                       <a:endParaRPr lang="en-US" sz="1400" dirty="0">
                         <a:latin typeface="Calibri" charset="0"/>
@@ -25390,7 +25390,7 @@
                           <a:ea typeface="Calibri" pitchFamily="34" charset="-122"/>
                           <a:cs typeface="Calibri" pitchFamily="34" charset="-120"/>
                         </a:rPr>
-                        <a:t>1144 автотеста проходят (v0.3.0, evidence.json), независимая проверка на Cedar, реестр утверждений: каждое число воспроизводится командой</a:t>
+                        <a:t>1155 автотестов проходят (v0.3.0, evidence.json), независимая проверка на Cedar, реестр утверждений: каждое число воспроизводится командой</a:t>
                       </a:r>
                       <a:endParaRPr lang="en-US" sz="1300" dirty="0">
                         <a:latin typeface="Calibri" charset="0"/>

</xml_diff>

<commit_message>
chore(M-14): regenerate evidence and deck
</commit_message>
<xml_diff>
--- a/submission/slides/Mandat_VTB.pptx
+++ b/submission/slides/Mandat_VTB.pptx
@@ -134,7 +134,7 @@
   <p:extLst>
     <p:ext uri="{521415D9-36F7-43E2-AB2F-B90AF26B5E84}">
       <p14:sectionLst xmlns:p14="http://schemas.microsoft.com/office/powerpoint/2010/main">
-        <p14:section name="Питч · 5 минут" id="{bb995f38-90ec-33dc-463c-26761da12218}">
+        <p14:section name="Питч · 5 минут" id="{5df47ccf-d680-d64b-2384-d8205528fd66}">
           <p14:sldIdLst>
             <p14:sldId id="256"/>
             <p14:sldId id="257"/>
@@ -152,7 +152,7 @@
             <p14:sldId id="269"/>
           </p14:sldIdLst>
         </p14:section>
-        <p14:section name="Приложение для вопросов жюри" id="{afb5a857-fb11-677c-28c4-d3975fd3c326}">
+        <p14:section name="Приложение для вопросов жюри" id="{3396805c-37e2-2af3-4b83-e5f6e245235e}">
           <p14:sldIdLst>
             <p14:sldId id="270"/>
             <p14:sldId id="271"/>
@@ -6183,7 +6183,7 @@
                   <a:schemeClr val="accent4"/>
                 </a:solidFill>
               </a:rPr>
-              <a:t>Источники: vtb.ru — «Комплект МЧД и КЭП» в «ВТБ Бизнес», 10.2026; репозиторий «Мандата» v0.3.0: 1155 автотестов, evidence.json от 15.10.2026</a:t>
+              <a:t>Источники: vtb.ru — «Комплект МЧД и КЭП» в «ВТБ Бизнес», 10.2026; репозиторий «Мандата» v0.3.0: 1172 автотеста, evidence.json от 15.10.2026</a:t>
             </a:r>
             <a:endParaRPr lang="en-US" sz="1000" dirty="0"/>
           </a:p>
@@ -7046,7 +7046,7 @@
                   <a:schemeClr val="bg1"/>
                 </a:solidFill>
               </a:rPr>
-              <a:t>1155 автотестов проходят, каждое число воспроизводится командой</a:t>
+              <a:t>1172 автотеста проходят, каждое число воспроизводится командой</a:t>
             </a:r>
             <a:endParaRPr lang="en-US" sz="1500" dirty="0"/>
           </a:p>
@@ -12430,7 +12430,7 @@
                           <a:ea typeface="Calibri" pitchFamily="34" charset="-122"/>
                           <a:cs typeface="Calibri" pitchFamily="34" charset="-120"/>
                         </a:rPr>
-                        <a:t>1155 автотестов; evidence.json</a:t>
+                        <a:t>1172 автотестов; evidence.json</a:t>
                       </a:r>
                       <a:endParaRPr lang="en-US" sz="1400" dirty="0">
                         <a:latin typeface="Calibri" charset="0"/>
@@ -25390,7 +25390,7 @@
                           <a:ea typeface="Calibri" pitchFamily="34" charset="-122"/>
                           <a:cs typeface="Calibri" pitchFamily="34" charset="-120"/>
                         </a:rPr>
-                        <a:t>1155 автотестов проходят (v0.3.0, evidence.json), независимая проверка на Cedar, реестр утверждений: каждое число воспроизводится командой</a:t>
+                        <a:t>1172 автотеста проходят (v0.3.0, evidence.json), независимая проверка на Cedar, реестр утверждений: каждое число воспроизводится командой</a:t>
                       </a:r>
                       <a:endParaRPr lang="en-US" sz="1300" dirty="0">
                         <a:latin typeface="Calibri" charset="0"/>

</xml_diff>

<commit_message>
test(M-14): targeted mutation tests for attestation and status_list (#34)
</commit_message>
<xml_diff>
--- a/submission/slides/Mandat_VTB.pptx
+++ b/submission/slides/Mandat_VTB.pptx
@@ -134,7 +134,7 @@
   <p:extLst>
     <p:ext uri="{521415D9-36F7-43E2-AB2F-B90AF26B5E84}">
       <p14:sectionLst xmlns:p14="http://schemas.microsoft.com/office/powerpoint/2010/main">
-        <p14:section name="Питч · 5 минут" id="{bb995f38-90ec-33dc-463c-26761da12218}">
+        <p14:section name="Питч · 5 минут" id="{5df47ccf-d680-d64b-2384-d8205528fd66}">
           <p14:sldIdLst>
             <p14:sldId id="256"/>
             <p14:sldId id="257"/>
@@ -152,7 +152,7 @@
             <p14:sldId id="269"/>
           </p14:sldIdLst>
         </p14:section>
-        <p14:section name="Приложение для вопросов жюри" id="{afb5a857-fb11-677c-28c4-d3975fd3c326}">
+        <p14:section name="Приложение для вопросов жюри" id="{3396805c-37e2-2af3-4b83-e5f6e245235e}">
           <p14:sldIdLst>
             <p14:sldId id="270"/>
             <p14:sldId id="271"/>
@@ -6183,7 +6183,7 @@
                   <a:schemeClr val="accent4"/>
                 </a:solidFill>
               </a:rPr>
-              <a:t>Источники: vtb.ru — «Комплект МЧД и КЭП» в «ВТБ Бизнес», 10.2026; репозиторий «Мандата» v0.3.0: 1155 автотестов, evidence.json от 15.10.2026</a:t>
+              <a:t>Источники: vtb.ru — «Комплект МЧД и КЭП» в «ВТБ Бизнес», 10.2026; репозиторий «Мандата» v0.3.0: 1172 автотеста, evidence.json от 15.10.2026</a:t>
             </a:r>
             <a:endParaRPr lang="en-US" sz="1000" dirty="0"/>
           </a:p>
@@ -7046,7 +7046,7 @@
                   <a:schemeClr val="bg1"/>
                 </a:solidFill>
               </a:rPr>
-              <a:t>1155 автотестов проходят, каждое число воспроизводится командой</a:t>
+              <a:t>1172 автотеста проходят, каждое число воспроизводится командой</a:t>
             </a:r>
             <a:endParaRPr lang="en-US" sz="1500" dirty="0"/>
           </a:p>
@@ -12430,7 +12430,7 @@
                           <a:ea typeface="Calibri" pitchFamily="34" charset="-122"/>
                           <a:cs typeface="Calibri" pitchFamily="34" charset="-120"/>
                         </a:rPr>
-                        <a:t>1155 автотестов; evidence.json</a:t>
+                        <a:t>1172 автотестов; evidence.json</a:t>
                       </a:r>
                       <a:endParaRPr lang="en-US" sz="1400" dirty="0">
                         <a:latin typeface="Calibri" charset="0"/>
@@ -25390,7 +25390,7 @@
                           <a:ea typeface="Calibri" pitchFamily="34" charset="-122"/>
                           <a:cs typeface="Calibri" pitchFamily="34" charset="-120"/>
                         </a:rPr>
-                        <a:t>1155 автотестов проходят (v0.3.0, evidence.json), независимая проверка на Cedar, реестр утверждений: каждое число воспроизводится командой</a:t>
+                        <a:t>1172 автотеста проходят (v0.3.0, evidence.json), независимая проверка на Cedar, реестр утверждений: каждое число воспроизводится командой</a:t>
                       </a:r>
                       <a:endParaRPr lang="en-US" sz="1300" dirty="0">
                         <a:latin typeface="Calibri" charset="0"/>

</xml_diff>

<commit_message>
chore(M-09): regenerate evidence and deck
</commit_message>
<xml_diff>
--- a/submission/slides/Mandat_VTB.pptx
+++ b/submission/slides/Mandat_VTB.pptx
@@ -134,7 +134,7 @@
   <p:extLst>
     <p:ext uri="{521415D9-36F7-43E2-AB2F-B90AF26B5E84}">
       <p14:sectionLst xmlns:p14="http://schemas.microsoft.com/office/powerpoint/2010/main">
-        <p14:section name="Питч · 5 минут" id="{5df47ccf-d680-d64b-2384-d8205528fd66}">
+        <p14:section name="Питч · 5 минут" id="{4d49ef39-379d-207e-65b5-a97f6dd66565}">
           <p14:sldIdLst>
             <p14:sldId id="256"/>
             <p14:sldId id="257"/>
@@ -152,7 +152,7 @@
             <p14:sldId id="269"/>
           </p14:sldIdLst>
         </p14:section>
-        <p14:section name="Приложение для вопросов жюри" id="{3396805c-37e2-2af3-4b83-e5f6e245235e}">
+        <p14:section name="Приложение для вопросов жюри" id="{1c60aae3-3a1b-11a7-dfc1-7f27ab5759ce}">
           <p14:sldIdLst>
             <p14:sldId id="270"/>
             <p14:sldId id="271"/>
@@ -6183,7 +6183,7 @@
                   <a:schemeClr val="accent4"/>
                 </a:solidFill>
               </a:rPr>
-              <a:t>Источники: vtb.ru — «Комплект МЧД и КЭП» в «ВТБ Бизнес», 10.2026; репозиторий «Мандата» v0.3.0: 1172 автотеста, evidence.json от 15.10.2026</a:t>
+              <a:t>Источники: vtb.ru — «Комплект МЧД и КЭП» в «ВТБ Бизнес», 10.2026; репозиторий «Мандата» v0.3.0: 1200 автотестов, evidence.json от 16.10.2026</a:t>
             </a:r>
             <a:endParaRPr lang="en-US" sz="1000" dirty="0"/>
           </a:p>
@@ -7046,7 +7046,7 @@
                   <a:schemeClr val="bg1"/>
                 </a:solidFill>
               </a:rPr>
-              <a:t>1172 автотеста проходят, каждое число воспроизводится командой</a:t>
+              <a:t>1200 автотестов проходят, каждое число воспроизводится командой</a:t>
             </a:r>
             <a:endParaRPr lang="en-US" sz="1500" dirty="0"/>
           </a:p>
@@ -12430,7 +12430,7 @@
                           <a:ea typeface="Calibri" pitchFamily="34" charset="-122"/>
                           <a:cs typeface="Calibri" pitchFamily="34" charset="-120"/>
                         </a:rPr>
-                        <a:t>1172 автотестов; evidence.json</a:t>
+                        <a:t>1200 автотестов; evidence.json</a:t>
                       </a:r>
                       <a:endParaRPr lang="en-US" sz="1400" dirty="0">
                         <a:latin typeface="Calibri" charset="0"/>
@@ -25390,7 +25390,7 @@
                           <a:ea typeface="Calibri" pitchFamily="34" charset="-122"/>
                           <a:cs typeface="Calibri" pitchFamily="34" charset="-120"/>
                         </a:rPr>
-                        <a:t>1172 автотеста проходят (v0.3.0, evidence.json), независимая проверка на Cedar, реестр утверждений: каждое число воспроизводится командой</a:t>
+                        <a:t>1200 автотестов проходят (v0.3.0, evidence.json), независимая проверка на Cedar, реестр утверждений: каждое число воспроизводится командой</a:t>
                       </a:r>
                       <a:endParaRPr lang="en-US" sz="1300" dirty="0">
                         <a:latin typeface="Calibri" charset="0"/>
@@ -33386,7 +33386,7 @@
                   <a:schemeClr val="accent4"/>
                 </a:solidFill>
               </a:rPr>
-              <a:t>Воспроизводится: mandat eval --per-defect 6; python -m pytest tests/test_properties.py tests/test_cedar.py; python scripts/bench.py → evidence.json (15.10.2026, v0.3.0)</a:t>
+              <a:t>Воспроизводится: mandat eval --per-defect 6; python -m pytest tests/test_properties.py tests/test_cedar.py; python scripts/bench.py → evidence.json (16.10.2026, v0.3.0)</a:t>
             </a:r>
             <a:endParaRPr lang="en-US" sz="1000" dirty="0"/>
           </a:p>

</xml_diff>

<commit_message>
feat(M-09): review roles, specializations and transition rules (#42)
</commit_message>
<xml_diff>
--- a/submission/slides/Mandat_VTB.pptx
+++ b/submission/slides/Mandat_VTB.pptx
@@ -134,7 +134,7 @@
   <p:extLst>
     <p:ext uri="{521415D9-36F7-43E2-AB2F-B90AF26B5E84}">
       <p14:sectionLst xmlns:p14="http://schemas.microsoft.com/office/powerpoint/2010/main">
-        <p14:section name="Питч · 5 минут" id="{5df47ccf-d680-d64b-2384-d8205528fd66}">
+        <p14:section name="Питч · 5 минут" id="{4d49ef39-379d-207e-65b5-a97f6dd66565}">
           <p14:sldIdLst>
             <p14:sldId id="256"/>
             <p14:sldId id="257"/>
@@ -152,7 +152,7 @@
             <p14:sldId id="269"/>
           </p14:sldIdLst>
         </p14:section>
-        <p14:section name="Приложение для вопросов жюри" id="{3396805c-37e2-2af3-4b83-e5f6e245235e}">
+        <p14:section name="Приложение для вопросов жюри" id="{1c60aae3-3a1b-11a7-dfc1-7f27ab5759ce}">
           <p14:sldIdLst>
             <p14:sldId id="270"/>
             <p14:sldId id="271"/>
@@ -6183,7 +6183,7 @@
                   <a:schemeClr val="accent4"/>
                 </a:solidFill>
               </a:rPr>
-              <a:t>Источники: vtb.ru — «Комплект МЧД и КЭП» в «ВТБ Бизнес», 10.2026; репозиторий «Мандата» v0.3.0: 1172 автотеста, evidence.json от 15.10.2026</a:t>
+              <a:t>Источники: vtb.ru — «Комплект МЧД и КЭП» в «ВТБ Бизнес», 10.2026; репозиторий «Мандата» v0.3.0: 1200 автотестов, evidence.json от 16.10.2026</a:t>
             </a:r>
             <a:endParaRPr lang="en-US" sz="1000" dirty="0"/>
           </a:p>
@@ -7046,7 +7046,7 @@
                   <a:schemeClr val="bg1"/>
                 </a:solidFill>
               </a:rPr>
-              <a:t>1172 автотеста проходят, каждое число воспроизводится командой</a:t>
+              <a:t>1200 автотестов проходят, каждое число воспроизводится командой</a:t>
             </a:r>
             <a:endParaRPr lang="en-US" sz="1500" dirty="0"/>
           </a:p>
@@ -12430,7 +12430,7 @@
                           <a:ea typeface="Calibri" pitchFamily="34" charset="-122"/>
                           <a:cs typeface="Calibri" pitchFamily="34" charset="-120"/>
                         </a:rPr>
-                        <a:t>1172 автотестов; evidence.json</a:t>
+                        <a:t>1200 автотестов; evidence.json</a:t>
                       </a:r>
                       <a:endParaRPr lang="en-US" sz="1400" dirty="0">
                         <a:latin typeface="Calibri" charset="0"/>
@@ -25390,7 +25390,7 @@
                           <a:ea typeface="Calibri" pitchFamily="34" charset="-122"/>
                           <a:cs typeface="Calibri" pitchFamily="34" charset="-120"/>
                         </a:rPr>
-                        <a:t>1172 автотеста проходят (v0.3.0, evidence.json), независимая проверка на Cedar, реестр утверждений: каждое число воспроизводится командой</a:t>
+                        <a:t>1200 автотестов проходят (v0.3.0, evidence.json), независимая проверка на Cedar, реестр утверждений: каждое число воспроизводится командой</a:t>
                       </a:r>
                       <a:endParaRPr lang="en-US" sz="1300" dirty="0">
                         <a:latin typeface="Calibri" charset="0"/>
@@ -33386,7 +33386,7 @@
                   <a:schemeClr val="accent4"/>
                 </a:solidFill>
               </a:rPr>
-              <a:t>Воспроизводится: mandat eval --per-defect 6; python -m pytest tests/test_properties.py tests/test_cedar.py; python scripts/bench.py → evidence.json (15.10.2026, v0.3.0)</a:t>
+              <a:t>Воспроизводится: mandat eval --per-defect 6; python -m pytest tests/test_properties.py tests/test_cedar.py; python scripts/bench.py → evidence.json (16.10.2026, v0.3.0)</a:t>
             </a:r>
             <a:endParaRPr lang="en-US" sz="1000" dirty="0"/>
           </a:p>

</xml_diff>

<commit_message>
feat(M-09): review state storage with version CAS (#44)
</commit_message>
<xml_diff>
--- a/submission/slides/Mandat_VTB.pptx
+++ b/submission/slides/Mandat_VTB.pptx
@@ -134,7 +134,7 @@
   <p:extLst>
     <p:ext uri="{521415D9-36F7-43E2-AB2F-B90AF26B5E84}">
       <p14:sectionLst xmlns:p14="http://schemas.microsoft.com/office/powerpoint/2010/main">
-        <p14:section name="Питч · 5 минут" id="{4d49ef39-379d-207e-65b5-a97f6dd66565}">
+        <p14:section name="Питч · 5 минут" id="{c698e1eb-7d10-9b6f-275a-bd41a8b3bb13}">
           <p14:sldIdLst>
             <p14:sldId id="256"/>
             <p14:sldId id="257"/>
@@ -152,7 +152,7 @@
             <p14:sldId id="269"/>
           </p14:sldIdLst>
         </p14:section>
-        <p14:section name="Приложение для вопросов жюри" id="{1c60aae3-3a1b-11a7-dfc1-7f27ab5759ce}">
+        <p14:section name="Приложение для вопросов жюри" id="{68eeefdd-8e4b-741a-0aa6-3c206428b117}">
           <p14:sldIdLst>
             <p14:sldId id="270"/>
             <p14:sldId id="271"/>
@@ -6183,7 +6183,7 @@
                   <a:schemeClr val="accent4"/>
                 </a:solidFill>
               </a:rPr>
-              <a:t>Источники: vtb.ru — «Комплект МЧД и КЭП» в «ВТБ Бизнес», 10.2026; репозиторий «Мандата» v0.3.0: 1200 автотестов, evidence.json от 16.10.2026</a:t>
+              <a:t>Источники: vtb.ru — «Комплект МЧД и КЭП» в «ВТБ Бизнес», 10.2026; репозиторий «Мандата» v0.3.0: 1222 автотеста, evidence.json от 16.10.2026</a:t>
             </a:r>
             <a:endParaRPr lang="en-US" sz="1000" dirty="0"/>
           </a:p>
@@ -7046,7 +7046,7 @@
                   <a:schemeClr val="bg1"/>
                 </a:solidFill>
               </a:rPr>
-              <a:t>1200 автотестов проходят, каждое число воспроизводится командой</a:t>
+              <a:t>1222 автотеста проходят, каждое число воспроизводится командой</a:t>
             </a:r>
             <a:endParaRPr lang="en-US" sz="1500" dirty="0"/>
           </a:p>
@@ -12430,7 +12430,7 @@
                           <a:ea typeface="Calibri" pitchFamily="34" charset="-122"/>
                           <a:cs typeface="Calibri" pitchFamily="34" charset="-120"/>
                         </a:rPr>
-                        <a:t>1200 автотестов; evidence.json</a:t>
+                        <a:t>1222 автотестов; evidence.json</a:t>
                       </a:r>
                       <a:endParaRPr lang="en-US" sz="1400" dirty="0">
                         <a:latin typeface="Calibri" charset="0"/>
@@ -25390,7 +25390,7 @@
                           <a:ea typeface="Calibri" pitchFamily="34" charset="-122"/>
                           <a:cs typeface="Calibri" pitchFamily="34" charset="-120"/>
                         </a:rPr>
-                        <a:t>1200 автотестов проходят (v0.3.0, evidence.json), независимая проверка на Cedar, реестр утверждений: каждое число воспроизводится командой</a:t>
+                        <a:t>1222 автотеста проходят (v0.3.0, evidence.json), независимая проверка на Cedar, реестр утверждений: каждое число воспроизводится командой</a:t>
                       </a:r>
                       <a:endParaRPr lang="en-US" sz="1300" dirty="0">
                         <a:latin typeface="Calibri" charset="0"/>

</xml_diff>

<commit_message>
chore: regenerate evidence and deck
</commit_message>
<xml_diff>
--- a/submission/slides/Mandat_VTB.pptx
+++ b/submission/slides/Mandat_VTB.pptx
@@ -134,7 +134,7 @@
   <p:extLst>
     <p:ext uri="{521415D9-36F7-43E2-AB2F-B90AF26B5E84}">
       <p14:sectionLst xmlns:p14="http://schemas.microsoft.com/office/powerpoint/2010/main">
-        <p14:section name="Питч · 5 минут" id="{c698e1eb-7d10-9b6f-275a-bd41a8b3bb13}">
+        <p14:section name="Питч · 5 минут" id="{622c27a8-95a2-0db7-65aa-e810fff81505}">
           <p14:sldIdLst>
             <p14:sldId id="256"/>
             <p14:sldId id="257"/>
@@ -152,7 +152,7 @@
             <p14:sldId id="269"/>
           </p14:sldIdLst>
         </p14:section>
-        <p14:section name="Приложение для вопросов жюри" id="{68eeefdd-8e4b-741a-0aa6-3c206428b117}">
+        <p14:section name="Приложение для вопросов жюри" id="{965baedc-fa4e-333e-4bcb-8b7541b7b7df}">
           <p14:sldIdLst>
             <p14:sldId id="270"/>
             <p14:sldId id="271"/>
@@ -6183,7 +6183,7 @@
                   <a:schemeClr val="accent4"/>
                 </a:solidFill>
               </a:rPr>
-              <a:t>Источники: vtb.ru — «Комплект МЧД и КЭП» в «ВТБ Бизнес», 10.2026; репозиторий «Мандата» v0.3.0: 1222 автотеста, evidence.json от 16.10.2026</a:t>
+              <a:t>Источники: vtb.ru — «Комплект МЧД и КЭП» в «ВТБ Бизнес», 10.2026; репозиторий «Мандата» v0.3.0: 1223 автотеста, evidence.json от 16.10.2026</a:t>
             </a:r>
             <a:endParaRPr lang="en-US" sz="1000" dirty="0"/>
           </a:p>
@@ -7046,7 +7046,7 @@
                   <a:schemeClr val="bg1"/>
                 </a:solidFill>
               </a:rPr>
-              <a:t>1222 автотеста проходят, каждое число воспроизводится командой</a:t>
+              <a:t>1223 автотеста проходят, каждое число воспроизводится командой</a:t>
             </a:r>
             <a:endParaRPr lang="en-US" sz="1500" dirty="0"/>
           </a:p>
@@ -12430,7 +12430,7 @@
                           <a:ea typeface="Calibri" pitchFamily="34" charset="-122"/>
                           <a:cs typeface="Calibri" pitchFamily="34" charset="-120"/>
                         </a:rPr>
-                        <a:t>1222 автотестов; evidence.json</a:t>
+                        <a:t>1223 автотестов; evidence.json</a:t>
                       </a:r>
                       <a:endParaRPr lang="en-US" sz="1400" dirty="0">
                         <a:latin typeface="Calibri" charset="0"/>
@@ -25390,7 +25390,7 @@
                           <a:ea typeface="Calibri" pitchFamily="34" charset="-122"/>
                           <a:cs typeface="Calibri" pitchFamily="34" charset="-120"/>
                         </a:rPr>
-                        <a:t>1222 автотеста проходят (v0.3.0, evidence.json), независимая проверка на Cedar, реестр утверждений: каждое число воспроизводится командой</a:t>
+                        <a:t>1223 автотеста проходят (v0.3.0, evidence.json), независимая проверка на Cedar, реестр утверждений: каждое число воспроизводится командой</a:t>
                       </a:r>
                       <a:endParaRPr lang="en-US" sz="1300" dirty="0">
                         <a:latin typeface="Calibri" charset="0"/>

</xml_diff>

<commit_message>
chore(M-09c): regenerate evidence and deck
</commit_message>
<xml_diff>
--- a/submission/slides/Mandat_VTB.pptx
+++ b/submission/slides/Mandat_VTB.pptx
@@ -134,7 +134,7 @@
   <p:extLst>
     <p:ext uri="{521415D9-36F7-43E2-AB2F-B90AF26B5E84}">
       <p14:sectionLst xmlns:p14="http://schemas.microsoft.com/office/powerpoint/2010/main">
-        <p14:section name="Питч · 5 минут" id="{c698e1eb-7d10-9b6f-275a-bd41a8b3bb13}">
+        <p14:section name="Питч · 5 минут" id="{933b954e-ddb8-2f06-01da-2255d5dd50b6}">
           <p14:sldIdLst>
             <p14:sldId id="256"/>
             <p14:sldId id="257"/>
@@ -152,7 +152,7 @@
             <p14:sldId id="269"/>
           </p14:sldIdLst>
         </p14:section>
-        <p14:section name="Приложение для вопросов жюри" id="{68eeefdd-8e4b-741a-0aa6-3c206428b117}">
+        <p14:section name="Приложение для вопросов жюри" id="{b72bf813-f76e-a0c6-e4ed-4bc79e6d3a9c}">
           <p14:sldIdLst>
             <p14:sldId id="270"/>
             <p14:sldId id="271"/>
@@ -6183,7 +6183,7 @@
                   <a:schemeClr val="accent4"/>
                 </a:solidFill>
               </a:rPr>
-              <a:t>Источники: vtb.ru — «Комплект МЧД и КЭП» в «ВТБ Бизнес», 10.2026; репозиторий «Мандата» v0.3.0: 1222 автотеста, evidence.json от 16.10.2026</a:t>
+              <a:t>Источники: vtb.ru — «Комплект МЧД и КЭП» в «ВТБ Бизнес», 10.2026; репозиторий «Мандата» v0.3.0: 1253 автотеста, evidence.json от 16.10.2026</a:t>
             </a:r>
             <a:endParaRPr lang="en-US" sz="1000" dirty="0"/>
           </a:p>
@@ -7046,7 +7046,7 @@
                   <a:schemeClr val="bg1"/>
                 </a:solidFill>
               </a:rPr>
-              <a:t>1222 автотеста проходят, каждое число воспроизводится командой</a:t>
+              <a:t>1253 автотеста проходят, каждое число воспроизводится командой</a:t>
             </a:r>
             <a:endParaRPr lang="en-US" sz="1500" dirty="0"/>
           </a:p>
@@ -12430,7 +12430,7 @@
                           <a:ea typeface="Calibri" pitchFamily="34" charset="-122"/>
                           <a:cs typeface="Calibri" pitchFamily="34" charset="-120"/>
                         </a:rPr>
-                        <a:t>1222 автотестов; evidence.json</a:t>
+                        <a:t>1253 автотестов; evidence.json</a:t>
                       </a:r>
                       <a:endParaRPr lang="en-US" sz="1400" dirty="0">
                         <a:latin typeface="Calibri" charset="0"/>
@@ -25390,7 +25390,7 @@
                           <a:ea typeface="Calibri" pitchFamily="34" charset="-122"/>
                           <a:cs typeface="Calibri" pitchFamily="34" charset="-120"/>
                         </a:rPr>
-                        <a:t>1222 автотеста проходят (v0.3.0, evidence.json), независимая проверка на Cedar, реестр утверждений: каждое число воспроизводится командой</a:t>
+                        <a:t>1253 автотеста проходят (v0.3.0, evidence.json), независимая проверка на Cedar, реестр утверждений: каждое число воспроизводится командой</a:t>
                       </a:r>
                       <a:endParaRPr lang="en-US" sz="1300" dirty="0">
                         <a:latin typeface="Calibri" charset="0"/>

</xml_diff>

<commit_message>
chore(M-05): regenerate evidence and deck
</commit_message>
<xml_diff>
--- a/submission/slides/Mandat_VTB.pptx
+++ b/submission/slides/Mandat_VTB.pptx
@@ -134,7 +134,7 @@
   <p:extLst>
     <p:ext uri="{521415D9-36F7-43E2-AB2F-B90AF26B5E84}">
       <p14:sectionLst xmlns:p14="http://schemas.microsoft.com/office/powerpoint/2010/main">
-        <p14:section name="Питч · 5 минут" id="{c698e1eb-7d10-9b6f-275a-bd41a8b3bb13}">
+        <p14:section name="Питч · 5 минут" id="{b733024e-17e0-d39e-5ffd-d3d1d1a97a69}">
           <p14:sldIdLst>
             <p14:sldId id="256"/>
             <p14:sldId id="257"/>
@@ -152,7 +152,7 @@
             <p14:sldId id="269"/>
           </p14:sldIdLst>
         </p14:section>
-        <p14:section name="Приложение для вопросов жюри" id="{68eeefdd-8e4b-741a-0aa6-3c206428b117}">
+        <p14:section name="Приложение для вопросов жюри" id="{0b3574ea-ab51-573b-5032-320213aaa677}">
           <p14:sldIdLst>
             <p14:sldId id="270"/>
             <p14:sldId id="271"/>
@@ -6183,7 +6183,7 @@
                   <a:schemeClr val="accent4"/>
                 </a:solidFill>
               </a:rPr>
-              <a:t>Источники: vtb.ru — «Комплект МЧД и КЭП» в «ВТБ Бизнес», 10.2026; репозиторий «Мандата» v0.3.0: 1222 автотеста, evidence.json от 16.10.2026</a:t>
+              <a:t>Источники: vtb.ru — «Комплект МЧД и КЭП» в «ВТБ Бизнес», 10.2026; репозиторий «Мандата» v0.3.0: 1244 автотеста, evidence.json от 16.10.2026</a:t>
             </a:r>
             <a:endParaRPr lang="en-US" sz="1000" dirty="0"/>
           </a:p>
@@ -7046,7 +7046,7 @@
                   <a:schemeClr val="bg1"/>
                 </a:solidFill>
               </a:rPr>
-              <a:t>1222 автотеста проходят, каждое число воспроизводится командой</a:t>
+              <a:t>1244 автотеста проходят, каждое число воспроизводится командой</a:t>
             </a:r>
             <a:endParaRPr lang="en-US" sz="1500" dirty="0"/>
           </a:p>
@@ -12430,7 +12430,7 @@
                           <a:ea typeface="Calibri" pitchFamily="34" charset="-122"/>
                           <a:cs typeface="Calibri" pitchFamily="34" charset="-120"/>
                         </a:rPr>
-                        <a:t>1222 автотестов; evidence.json</a:t>
+                        <a:t>1244 автотестов; evidence.json</a:t>
                       </a:r>
                       <a:endParaRPr lang="en-US" sz="1400" dirty="0">
                         <a:latin typeface="Calibri" charset="0"/>
@@ -25390,7 +25390,7 @@
                           <a:ea typeface="Calibri" pitchFamily="34" charset="-122"/>
                           <a:cs typeface="Calibri" pitchFamily="34" charset="-120"/>
                         </a:rPr>
-                        <a:t>1222 автотеста проходят (v0.3.0, evidence.json), независимая проверка на Cedar, реестр утверждений: каждое число воспроизводится командой</a:t>
+                        <a:t>1244 автотеста проходят (v0.3.0, evidence.json), независимая проверка на Cedar, реестр утверждений: каждое число воспроизводится командой</a:t>
                       </a:r>
                       <a:endParaRPr lang="en-US" sz="1300" dirty="0">
                         <a:latin typeface="Calibri" charset="0"/>

</xml_diff>

<commit_message>
ci: run store tests against real Redis (#46)
CI job redis runs the storage and review CAS tests against a digest-pinned redis:7; the redis_store fixture uses MANDAT_TEST_REDIS_URL when set and fakeredis otherwise.
</commit_message>
<xml_diff>
--- a/submission/slides/Mandat_VTB.pptx
+++ b/submission/slides/Mandat_VTB.pptx
@@ -134,7 +134,7 @@
   <p:extLst>
     <p:ext uri="{521415D9-36F7-43E2-AB2F-B90AF26B5E84}">
       <p14:sectionLst xmlns:p14="http://schemas.microsoft.com/office/powerpoint/2010/main">
-        <p14:section name="Питч · 5 минут" id="{c698e1eb-7d10-9b6f-275a-bd41a8b3bb13}">
+        <p14:section name="Питч · 5 минут" id="{622c27a8-95a2-0db7-65aa-e810fff81505}">
           <p14:sldIdLst>
             <p14:sldId id="256"/>
             <p14:sldId id="257"/>
@@ -152,7 +152,7 @@
             <p14:sldId id="269"/>
           </p14:sldIdLst>
         </p14:section>
-        <p14:section name="Приложение для вопросов жюри" id="{68eeefdd-8e4b-741a-0aa6-3c206428b117}">
+        <p14:section name="Приложение для вопросов жюри" id="{965baedc-fa4e-333e-4bcb-8b7541b7b7df}">
           <p14:sldIdLst>
             <p14:sldId id="270"/>
             <p14:sldId id="271"/>
@@ -6183,7 +6183,7 @@
                   <a:schemeClr val="accent4"/>
                 </a:solidFill>
               </a:rPr>
-              <a:t>Источники: vtb.ru — «Комплект МЧД и КЭП» в «ВТБ Бизнес», 10.2026; репозиторий «Мандата» v0.3.0: 1222 автотеста, evidence.json от 16.10.2026</a:t>
+              <a:t>Источники: vtb.ru — «Комплект МЧД и КЭП» в «ВТБ Бизнес», 10.2026; репозиторий «Мандата» v0.3.0: 1223 автотеста, evidence.json от 16.10.2026</a:t>
             </a:r>
             <a:endParaRPr lang="en-US" sz="1000" dirty="0"/>
           </a:p>
@@ -7046,7 +7046,7 @@
                   <a:schemeClr val="bg1"/>
                 </a:solidFill>
               </a:rPr>
-              <a:t>1222 автотеста проходят, каждое число воспроизводится командой</a:t>
+              <a:t>1223 автотеста проходят, каждое число воспроизводится командой</a:t>
             </a:r>
             <a:endParaRPr lang="en-US" sz="1500" dirty="0"/>
           </a:p>
@@ -12430,7 +12430,7 @@
                           <a:ea typeface="Calibri" pitchFamily="34" charset="-122"/>
                           <a:cs typeface="Calibri" pitchFamily="34" charset="-120"/>
                         </a:rPr>
-                        <a:t>1222 автотестов; evidence.json</a:t>
+                        <a:t>1223 автотестов; evidence.json</a:t>
                       </a:r>
                       <a:endParaRPr lang="en-US" sz="1400" dirty="0">
                         <a:latin typeface="Calibri" charset="0"/>
@@ -25390,7 +25390,7 @@
                           <a:ea typeface="Calibri" pitchFamily="34" charset="-122"/>
                           <a:cs typeface="Calibri" pitchFamily="34" charset="-120"/>
                         </a:rPr>
-                        <a:t>1222 автотеста проходят (v0.3.0, evidence.json), независимая проверка на Cedar, реестр утверждений: каждое число воспроизводится командой</a:t>
+                        <a:t>1223 автотеста проходят (v0.3.0, evidence.json), независимая проверка на Cedar, реестр утверждений: каждое число воспроизводится командой</a:t>
                       </a:r>
                       <a:endParaRPr lang="en-US" sz="1300" dirty="0">
                         <a:latin typeface="Calibri" charset="0"/>

</xml_diff>

<commit_message>
feat(M-09c): review API routes, queue and configurable SLA (#48)
Closes #47, #41, #43.
</commit_message>
<xml_diff>
--- a/submission/slides/Mandat_VTB.pptx
+++ b/submission/slides/Mandat_VTB.pptx
@@ -134,7 +134,7 @@
   <p:extLst>
     <p:ext uri="{521415D9-36F7-43E2-AB2F-B90AF26B5E84}">
       <p14:sectionLst xmlns:p14="http://schemas.microsoft.com/office/powerpoint/2010/main">
-        <p14:section name="Питч · 5 минут" id="{622c27a8-95a2-0db7-65aa-e810fff81505}">
+        <p14:section name="Питч · 5 минут" id="{a0fb3028-9cb1-9984-4b58-a88d97928ebe}">
           <p14:sldIdLst>
             <p14:sldId id="256"/>
             <p14:sldId id="257"/>
@@ -152,7 +152,7 @@
             <p14:sldId id="269"/>
           </p14:sldIdLst>
         </p14:section>
-        <p14:section name="Приложение для вопросов жюри" id="{965baedc-fa4e-333e-4bcb-8b7541b7b7df}">
+        <p14:section name="Приложение для вопросов жюри" id="{7ab746f4-3934-4728-2c8a-126ab9e2593b}">
           <p14:sldIdLst>
             <p14:sldId id="270"/>
             <p14:sldId id="271"/>
@@ -6183,7 +6183,7 @@
                   <a:schemeClr val="accent4"/>
                 </a:solidFill>
               </a:rPr>
-              <a:t>Источники: vtb.ru — «Комплект МЧД и КЭП» в «ВТБ Бизнес», 10.2026; репозиторий «Мандата» v0.3.0: 1223 автотеста, evidence.json от 16.10.2026</a:t>
+              <a:t>Источники: vtb.ru — «Комплект МЧД и КЭП» в «ВТБ Бизнес», 10.2026; репозиторий «Мандата» v0.3.0: 1258 автотестов, evidence.json от 16.10.2026</a:t>
             </a:r>
             <a:endParaRPr lang="en-US" sz="1000" dirty="0"/>
           </a:p>
@@ -7046,7 +7046,7 @@
                   <a:schemeClr val="bg1"/>
                 </a:solidFill>
               </a:rPr>
-              <a:t>1223 автотеста проходят, каждое число воспроизводится командой</a:t>
+              <a:t>1258 автотестов проходят, каждое число воспроизводится командой</a:t>
             </a:r>
             <a:endParaRPr lang="en-US" sz="1500" dirty="0"/>
           </a:p>
@@ -12430,7 +12430,7 @@
                           <a:ea typeface="Calibri" pitchFamily="34" charset="-122"/>
                           <a:cs typeface="Calibri" pitchFamily="34" charset="-120"/>
                         </a:rPr>
-                        <a:t>1223 автотестов; evidence.json</a:t>
+                        <a:t>1258 автотестов; evidence.json</a:t>
                       </a:r>
                       <a:endParaRPr lang="en-US" sz="1400" dirty="0">
                         <a:latin typeface="Calibri" charset="0"/>
@@ -25390,7 +25390,7 @@
                           <a:ea typeface="Calibri" pitchFamily="34" charset="-122"/>
                           <a:cs typeface="Calibri" pitchFamily="34" charset="-120"/>
                         </a:rPr>
-                        <a:t>1223 автотеста проходят (v0.3.0, evidence.json), независимая проверка на Cedar, реестр утверждений: каждое число воспроизводится командой</a:t>
+                        <a:t>1258 автотестов проходят (v0.3.0, evidence.json), независимая проверка на Cedar, реестр утверждений: каждое число воспроизводится командой</a:t>
                       </a:r>
                       <a:endParaRPr lang="en-US" sz="1300" dirty="0">
                         <a:latin typeface="Calibri" charset="0"/>

</xml_diff>

<commit_message>
fix(M-05): cut birth date and address, send only authority lines to the model (#50)
Closes #49.
</commit_message>
<xml_diff>
--- a/submission/slides/Mandat_VTB.pptx
+++ b/submission/slides/Mandat_VTB.pptx
@@ -134,7 +134,7 @@
   <p:extLst>
     <p:ext uri="{521415D9-36F7-43E2-AB2F-B90AF26B5E84}">
       <p14:sectionLst xmlns:p14="http://schemas.microsoft.com/office/powerpoint/2010/main">
-        <p14:section name="Питч · 5 минут" id="{a0fb3028-9cb1-9984-4b58-a88d97928ebe}">
+        <p14:section name="Питч · 5 минут" id="{edb45d78-0ae2-328f-1092-d177ba8f7556}">
           <p14:sldIdLst>
             <p14:sldId id="256"/>
             <p14:sldId id="257"/>
@@ -152,7 +152,7 @@
             <p14:sldId id="269"/>
           </p14:sldIdLst>
         </p14:section>
-        <p14:section name="Приложение для вопросов жюри" id="{7ab746f4-3934-4728-2c8a-126ab9e2593b}">
+        <p14:section name="Приложение для вопросов жюри" id="{dbf914e0-87f8-13d4-492f-bdb675a3bb7d}">
           <p14:sldIdLst>
             <p14:sldId id="270"/>
             <p14:sldId id="271"/>
@@ -6183,7 +6183,7 @@
                   <a:schemeClr val="accent4"/>
                 </a:solidFill>
               </a:rPr>
-              <a:t>Источники: vtb.ru — «Комплект МЧД и КЭП» в «ВТБ Бизнес», 10.2026; репозиторий «Мандата» v0.3.0: 1258 автотестов, evidence.json от 16.10.2026</a:t>
+              <a:t>Источники: vtb.ru — «Комплект МЧД и КЭП» в «ВТБ Бизнес», 10.2026; репозиторий «Мандата» v0.3.0: 1327 автотестов, evidence.json от 16.10.2026</a:t>
             </a:r>
             <a:endParaRPr lang="en-US" sz="1000" dirty="0"/>
           </a:p>
@@ -7046,7 +7046,7 @@
                   <a:schemeClr val="bg1"/>
                 </a:solidFill>
               </a:rPr>
-              <a:t>1258 автотестов проходят, каждое число воспроизводится командой</a:t>
+              <a:t>1327 автотестов проходят, каждое число воспроизводится командой</a:t>
             </a:r>
             <a:endParaRPr lang="en-US" sz="1500" dirty="0"/>
           </a:p>
@@ -12430,7 +12430,7 @@
                           <a:ea typeface="Calibri" pitchFamily="34" charset="-122"/>
                           <a:cs typeface="Calibri" pitchFamily="34" charset="-120"/>
                         </a:rPr>
-                        <a:t>1258 автотестов; evidence.json</a:t>
+                        <a:t>1327 автотестов; evidence.json</a:t>
                       </a:r>
                       <a:endParaRPr lang="en-US" sz="1400" dirty="0">
                         <a:latin typeface="Calibri" charset="0"/>
@@ -25390,7 +25390,7 @@
                           <a:ea typeface="Calibri" pitchFamily="34" charset="-122"/>
                           <a:cs typeface="Calibri" pitchFamily="34" charset="-120"/>
                         </a:rPr>
-                        <a:t>1258 автотестов проходят (v0.3.0, evidence.json), независимая проверка на Cedar, реестр утверждений: каждое число воспроизводится командой</a:t>
+                        <a:t>1327 автотестов проходят (v0.3.0, evidence.json), независимая проверка на Cedar, реестр утверждений: каждое число воспроизводится командой</a:t>
                       </a:r>
                       <a:endParaRPr lang="en-US" sz="1300" dirty="0">
                         <a:latin typeface="Calibri" charset="0"/>

</xml_diff>

<commit_message>
chore(M-05): keep slides at main version
</commit_message>
<xml_diff>
--- a/submission/slides/Mandat_VTB.pptx
+++ b/submission/slides/Mandat_VTB.pptx
@@ -134,7 +134,7 @@
   <p:extLst>
     <p:ext uri="{521415D9-36F7-43E2-AB2F-B90AF26B5E84}">
       <p14:sectionLst xmlns:p14="http://schemas.microsoft.com/office/powerpoint/2010/main">
-        <p14:section name="Питч · 5 минут" id="{8174e5ea-008a-241f-3fbd-922cda515422}">
+        <p14:section name="Питч · 5 минут" id="{edb45d78-0ae2-328f-1092-d177ba8f7556}">
           <p14:sldIdLst>
             <p14:sldId id="256"/>
             <p14:sldId id="257"/>
@@ -152,7 +152,7 @@
             <p14:sldId id="269"/>
           </p14:sldIdLst>
         </p14:section>
-        <p14:section name="Приложение для вопросов жюри" id="{a57336c7-ba8e-c447-4746-f07861f76033}">
+        <p14:section name="Приложение для вопросов жюри" id="{dbf914e0-87f8-13d4-492f-bdb675a3bb7d}">
           <p14:sldIdLst>
             <p14:sldId id="270"/>
             <p14:sldId id="271"/>
@@ -6183,7 +6183,7 @@
                   <a:schemeClr val="accent4"/>
                 </a:solidFill>
               </a:rPr>
-              <a:t>Источники: vtb.ru — «Комплект МЧД и КЭП» в «ВТБ Бизнес», 10.2026; репозиторий «Мандата» v0.3.0: 1354 автотеста, evidence.json от 16.10.2026</a:t>
+              <a:t>Источники: vtb.ru — «Комплект МЧД и КЭП» в «ВТБ Бизнес», 10.2026; репозиторий «Мандата» v0.3.0: 1327 автотестов, evidence.json от 16.10.2026</a:t>
             </a:r>
             <a:endParaRPr lang="en-US" sz="1000" dirty="0"/>
           </a:p>
@@ -7046,7 +7046,7 @@
                   <a:schemeClr val="bg1"/>
                 </a:solidFill>
               </a:rPr>
-              <a:t>1354 автотеста проходят, каждое число воспроизводится командой</a:t>
+              <a:t>1327 автотестов проходят, каждое число воспроизводится командой</a:t>
             </a:r>
             <a:endParaRPr lang="en-US" sz="1500" dirty="0"/>
           </a:p>
@@ -12430,7 +12430,7 @@
                           <a:ea typeface="Calibri" pitchFamily="34" charset="-122"/>
                           <a:cs typeface="Calibri" pitchFamily="34" charset="-120"/>
                         </a:rPr>
-                        <a:t>1354 автотестов; evidence.json</a:t>
+                        <a:t>1327 автотестов; evidence.json</a:t>
                       </a:r>
                       <a:endParaRPr lang="en-US" sz="1400" dirty="0">
                         <a:latin typeface="Calibri" charset="0"/>
@@ -25390,7 +25390,7 @@
                           <a:ea typeface="Calibri" pitchFamily="34" charset="-122"/>
                           <a:cs typeface="Calibri" pitchFamily="34" charset="-120"/>
                         </a:rPr>
-                        <a:t>1354 автотеста проходят (v0.3.0, evidence.json), независимая проверка на Cedar, реестр утверждений: каждое число воспроизводится командой</a:t>
+                        <a:t>1327 автотестов проходят (v0.3.0, evidence.json), независимая проверка на Cedar, реестр утверждений: каждое число воспроизводится командой</a:t>
                       </a:r>
                       <a:endParaRPr lang="en-US" sz="1300" dirty="0">
                         <a:latin typeface="Calibri" charset="0"/>

</xml_diff>

<commit_message>
revert(M-05): restore slides rebuilt from evidence
This reverts commit 959c68c1617dc6933a05c8953477f70fbc00eb2f.
</commit_message>
<xml_diff>
--- a/submission/slides/Mandat_VTB.pptx
+++ b/submission/slides/Mandat_VTB.pptx
@@ -134,7 +134,7 @@
   <p:extLst>
     <p:ext uri="{521415D9-36F7-43E2-AB2F-B90AF26B5E84}">
       <p14:sectionLst xmlns:p14="http://schemas.microsoft.com/office/powerpoint/2010/main">
-        <p14:section name="Питч · 5 минут" id="{edb45d78-0ae2-328f-1092-d177ba8f7556}">
+        <p14:section name="Питч · 5 минут" id="{8174e5ea-008a-241f-3fbd-922cda515422}">
           <p14:sldIdLst>
             <p14:sldId id="256"/>
             <p14:sldId id="257"/>
@@ -152,7 +152,7 @@
             <p14:sldId id="269"/>
           </p14:sldIdLst>
         </p14:section>
-        <p14:section name="Приложение для вопросов жюри" id="{dbf914e0-87f8-13d4-492f-bdb675a3bb7d}">
+        <p14:section name="Приложение для вопросов жюри" id="{a57336c7-ba8e-c447-4746-f07861f76033}">
           <p14:sldIdLst>
             <p14:sldId id="270"/>
             <p14:sldId id="271"/>
@@ -6183,7 +6183,7 @@
                   <a:schemeClr val="accent4"/>
                 </a:solidFill>
               </a:rPr>
-              <a:t>Источники: vtb.ru — «Комплект МЧД и КЭП» в «ВТБ Бизнес», 10.2026; репозиторий «Мандата» v0.3.0: 1327 автотестов, evidence.json от 16.10.2026</a:t>
+              <a:t>Источники: vtb.ru — «Комплект МЧД и КЭП» в «ВТБ Бизнес», 10.2026; репозиторий «Мандата» v0.3.0: 1354 автотеста, evidence.json от 16.10.2026</a:t>
             </a:r>
             <a:endParaRPr lang="en-US" sz="1000" dirty="0"/>
           </a:p>
@@ -7046,7 +7046,7 @@
                   <a:schemeClr val="bg1"/>
                 </a:solidFill>
               </a:rPr>
-              <a:t>1327 автотестов проходят, каждое число воспроизводится командой</a:t>
+              <a:t>1354 автотеста проходят, каждое число воспроизводится командой</a:t>
             </a:r>
             <a:endParaRPr lang="en-US" sz="1500" dirty="0"/>
           </a:p>
@@ -12430,7 +12430,7 @@
                           <a:ea typeface="Calibri" pitchFamily="34" charset="-122"/>
                           <a:cs typeface="Calibri" pitchFamily="34" charset="-120"/>
                         </a:rPr>
-                        <a:t>1327 автотестов; evidence.json</a:t>
+                        <a:t>1354 автотестов; evidence.json</a:t>
                       </a:r>
                       <a:endParaRPr lang="en-US" sz="1400" dirty="0">
                         <a:latin typeface="Calibri" charset="0"/>
@@ -25390,7 +25390,7 @@
                           <a:ea typeface="Calibri" pitchFamily="34" charset="-122"/>
                           <a:cs typeface="Calibri" pitchFamily="34" charset="-120"/>
                         </a:rPr>
-                        <a:t>1327 автотестов проходят (v0.3.0, evidence.json), независимая проверка на Cedar, реестр утверждений: каждое число воспроизводится командой</a:t>
+                        <a:t>1354 автотеста проходят (v0.3.0, evidence.json), независимая проверка на Cedar, реестр утверждений: каждое число воспроизводится командой</a:t>
                       </a:r>
                       <a:endParaRPr lang="en-US" sz="1300" dirty="0">
                         <a:latin typeface="Calibri" charset="0"/>

</xml_diff>

<commit_message>
chore(M-05): clean generator names from deck metadata
</commit_message>
<xml_diff>
--- a/submission/slides/Mandat_VTB.pptx
+++ b/submission/slides/Mandat_VTB.pptx
@@ -134,7 +134,7 @@
   <p:extLst>
     <p:ext uri="{521415D9-36F7-43E2-AB2F-B90AF26B5E84}">
       <p14:sectionLst xmlns:p14="http://schemas.microsoft.com/office/powerpoint/2010/main">
-        <p14:section name="Питч · 5 минут" id="{8174e5ea-008a-241f-3fbd-922cda515422}">
+        <p14:section name="Питч · 5 минут" id="{6555bb59-6f1a-7227-a94c-e7581679f3d4}">
           <p14:sldIdLst>
             <p14:sldId id="256"/>
             <p14:sldId id="257"/>
@@ -152,7 +152,7 @@
             <p14:sldId id="269"/>
           </p14:sldIdLst>
         </p14:section>
-        <p14:section name="Приложение для вопросов жюри" id="{a57336c7-ba8e-c447-4746-f07861f76033}">
+        <p14:section name="Приложение для вопросов жюри" id="{a24dda74-dd30-1bee-cce2-d63489ded22c}">
           <p14:sldIdLst>
             <p14:sldId id="270"/>
             <p14:sldId id="271"/>

</xml_diff>

<commit_message>
chore(SOTA-M1): regenerate evidence and deck
</commit_message>
<xml_diff>
--- a/submission/slides/Mandat_VTB.pptx
+++ b/submission/slides/Mandat_VTB.pptx
@@ -134,7 +134,7 @@
   <p:extLst>
     <p:ext uri="{521415D9-36F7-43E2-AB2F-B90AF26B5E84}">
       <p14:sectionLst xmlns:p14="http://schemas.microsoft.com/office/powerpoint/2010/main">
-        <p14:section name="Питч · 5 минут" id="{edb45d78-0ae2-328f-1092-d177ba8f7556}">
+        <p14:section name="Питч · 5 минут" id="{20cc72ab-383c-1feb-af12-5e36b43830cf}">
           <p14:sldIdLst>
             <p14:sldId id="256"/>
             <p14:sldId id="257"/>
@@ -152,7 +152,7 @@
             <p14:sldId id="269"/>
           </p14:sldIdLst>
         </p14:section>
-        <p14:section name="Приложение для вопросов жюри" id="{dbf914e0-87f8-13d4-492f-bdb675a3bb7d}">
+        <p14:section name="Приложение для вопросов жюри" id="{e1128119-9ea1-144d-aa70-9ecc617337ee}">
           <p14:sldIdLst>
             <p14:sldId id="270"/>
             <p14:sldId id="271"/>
@@ -6183,7 +6183,7 @@
                   <a:schemeClr val="accent4"/>
                 </a:solidFill>
               </a:rPr>
-              <a:t>Источники: vtb.ru — «Комплект МЧД и КЭП» в «ВТБ Бизнес», 10.2026; репозиторий «Мандата» v0.3.0: 1327 автотестов, evidence.json от 16.10.2026</a:t>
+              <a:t>Источники: vtb.ru — «Комплект МЧД и КЭП» в «ВТБ Бизнес», 10.2026; репозиторий «Мандата» v0.3.0: 1348 автотестов, evidence.json от 16.10.2026</a:t>
             </a:r>
             <a:endParaRPr lang="en-US" sz="1000" dirty="0"/>
           </a:p>
@@ -7046,7 +7046,7 @@
                   <a:schemeClr val="bg1"/>
                 </a:solidFill>
               </a:rPr>
-              <a:t>1327 автотестов проходят, каждое число воспроизводится командой</a:t>
+              <a:t>1348 автотестов проходят, каждое число воспроизводится командой</a:t>
             </a:r>
             <a:endParaRPr lang="en-US" sz="1500" dirty="0"/>
           </a:p>
@@ -12430,7 +12430,7 @@
                           <a:ea typeface="Calibri" pitchFamily="34" charset="-122"/>
                           <a:cs typeface="Calibri" pitchFamily="34" charset="-120"/>
                         </a:rPr>
-                        <a:t>1327 автотестов; evidence.json</a:t>
+                        <a:t>1348 автотестов; evidence.json</a:t>
                       </a:r>
                       <a:endParaRPr lang="en-US" sz="1400" dirty="0">
                         <a:latin typeface="Calibri" charset="0"/>
@@ -25390,7 +25390,7 @@
                           <a:ea typeface="Calibri" pitchFamily="34" charset="-122"/>
                           <a:cs typeface="Calibri" pitchFamily="34" charset="-120"/>
                         </a:rPr>
-                        <a:t>1327 автотестов проходят (v0.3.0, evidence.json), независимая проверка на Cedar, реестр утверждений: каждое число воспроизводится командой</a:t>
+                        <a:t>1348 автотестов проходят (v0.3.0, evidence.json), независимая проверка на Cedar, реестр утверждений: каждое число воспроизводится командой</a:t>
                       </a:r>
                       <a:endParaRPr lang="en-US" sz="1300" dirty="0">
                         <a:latin typeface="Calibri" charset="0"/>

</xml_diff>

<commit_message>
fix(M-05): accept only redacted messages in the model client (#52)
Closes #51.
</commit_message>
<xml_diff>
--- a/submission/slides/Mandat_VTB.pptx
+++ b/submission/slides/Mandat_VTB.pptx
@@ -134,7 +134,7 @@
   <p:extLst>
     <p:ext uri="{521415D9-36F7-43E2-AB2F-B90AF26B5E84}">
       <p14:sectionLst xmlns:p14="http://schemas.microsoft.com/office/powerpoint/2010/main">
-        <p14:section name="Питч · 5 минут" id="{edb45d78-0ae2-328f-1092-d177ba8f7556}">
+        <p14:section name="Питч · 5 минут" id="{6555bb59-6f1a-7227-a94c-e7581679f3d4}">
           <p14:sldIdLst>
             <p14:sldId id="256"/>
             <p14:sldId id="257"/>
@@ -152,7 +152,7 @@
             <p14:sldId id="269"/>
           </p14:sldIdLst>
         </p14:section>
-        <p14:section name="Приложение для вопросов жюри" id="{dbf914e0-87f8-13d4-492f-bdb675a3bb7d}">
+        <p14:section name="Приложение для вопросов жюри" id="{a24dda74-dd30-1bee-cce2-d63489ded22c}">
           <p14:sldIdLst>
             <p14:sldId id="270"/>
             <p14:sldId id="271"/>
@@ -6183,7 +6183,7 @@
                   <a:schemeClr val="accent4"/>
                 </a:solidFill>
               </a:rPr>
-              <a:t>Источники: vtb.ru — «Комплект МЧД и КЭП» в «ВТБ Бизнес», 10.2026; репозиторий «Мандата» v0.3.0: 1327 автотестов, evidence.json от 16.10.2026</a:t>
+              <a:t>Источники: vtb.ru — «Комплект МЧД и КЭП» в «ВТБ Бизнес», 10.2026; репозиторий «Мандата» v0.3.0: 1354 автотеста, evidence.json от 16.10.2026</a:t>
             </a:r>
             <a:endParaRPr lang="en-US" sz="1000" dirty="0"/>
           </a:p>
@@ -7046,7 +7046,7 @@
                   <a:schemeClr val="bg1"/>
                 </a:solidFill>
               </a:rPr>
-              <a:t>1327 автотестов проходят, каждое число воспроизводится командой</a:t>
+              <a:t>1354 автотеста проходят, каждое число воспроизводится командой</a:t>
             </a:r>
             <a:endParaRPr lang="en-US" sz="1500" dirty="0"/>
           </a:p>
@@ -12430,7 +12430,7 @@
                           <a:ea typeface="Calibri" pitchFamily="34" charset="-122"/>
                           <a:cs typeface="Calibri" pitchFamily="34" charset="-120"/>
                         </a:rPr>
-                        <a:t>1327 автотестов; evidence.json</a:t>
+                        <a:t>1354 автотестов; evidence.json</a:t>
                       </a:r>
                       <a:endParaRPr lang="en-US" sz="1400" dirty="0">
                         <a:latin typeface="Calibri" charset="0"/>
@@ -25390,7 +25390,7 @@
                           <a:ea typeface="Calibri" pitchFamily="34" charset="-122"/>
                           <a:cs typeface="Calibri" pitchFamily="34" charset="-120"/>
                         </a:rPr>
-                        <a:t>1327 автотестов проходят (v0.3.0, evidence.json), независимая проверка на Cedar, реестр утверждений: каждое число воспроизводится командой</a:t>
+                        <a:t>1354 автотеста проходят (v0.3.0, evidence.json), независимая проверка на Cedar, реестр утверждений: каждое число воспроизводится командой</a:t>
                       </a:r>
                       <a:endParaRPr lang="en-US" sz="1300" dirty="0">
                         <a:latin typeface="Calibri" charset="0"/>

</xml_diff>

<commit_message>
feat(SOTA-M1): offline snapshot of the FNS authority classifier (#55)
Closes #53.
</commit_message>
<xml_diff>
--- a/submission/slides/Mandat_VTB.pptx
+++ b/submission/slides/Mandat_VTB.pptx
@@ -134,7 +134,7 @@
   <p:extLst>
     <p:ext uri="{521415D9-36F7-43E2-AB2F-B90AF26B5E84}">
       <p14:sectionLst xmlns:p14="http://schemas.microsoft.com/office/powerpoint/2010/main">
-        <p14:section name="Питч · 5 минут" id="{6555bb59-6f1a-7227-a94c-e7581679f3d4}">
+        <p14:section name="Питч · 5 минут" id="{0d487e5d-13d1-27a9-c751-c94e621acd17}">
           <p14:sldIdLst>
             <p14:sldId id="256"/>
             <p14:sldId id="257"/>
@@ -152,7 +152,7 @@
             <p14:sldId id="269"/>
           </p14:sldIdLst>
         </p14:section>
-        <p14:section name="Приложение для вопросов жюри" id="{a24dda74-dd30-1bee-cce2-d63489ded22c}">
+        <p14:section name="Приложение для вопросов жюри" id="{f7d1debb-f8d1-30ff-679c-814fc922e812}">
           <p14:sldIdLst>
             <p14:sldId id="270"/>
             <p14:sldId id="271"/>
@@ -6183,7 +6183,7 @@
                   <a:schemeClr val="accent4"/>
                 </a:solidFill>
               </a:rPr>
-              <a:t>Источники: vtb.ru — «Комплект МЧД и КЭП» в «ВТБ Бизнес», 10.2026; репозиторий «Мандата» v0.3.0: 1354 автотеста, evidence.json от 16.10.2026</a:t>
+              <a:t>Источники: vtb.ru — «Комплект МЧД и КЭП» в «ВТБ Бизнес», 10.2026; репозиторий «Мандата» v0.3.0: 1375 автотестов, evidence.json от 16.10.2026</a:t>
             </a:r>
             <a:endParaRPr lang="en-US" sz="1000" dirty="0"/>
           </a:p>
@@ -7046,7 +7046,7 @@
                   <a:schemeClr val="bg1"/>
                 </a:solidFill>
               </a:rPr>
-              <a:t>1354 автотеста проходят, каждое число воспроизводится командой</a:t>
+              <a:t>1375 автотестов проходят, каждое число воспроизводится командой</a:t>
             </a:r>
             <a:endParaRPr lang="en-US" sz="1500" dirty="0"/>
           </a:p>
@@ -12430,7 +12430,7 @@
                           <a:ea typeface="Calibri" pitchFamily="34" charset="-122"/>
                           <a:cs typeface="Calibri" pitchFamily="34" charset="-120"/>
                         </a:rPr>
-                        <a:t>1354 автотестов; evidence.json</a:t>
+                        <a:t>1375 автотестов; evidence.json</a:t>
                       </a:r>
                       <a:endParaRPr lang="en-US" sz="1400" dirty="0">
                         <a:latin typeface="Calibri" charset="0"/>
@@ -25390,7 +25390,7 @@
                           <a:ea typeface="Calibri" pitchFamily="34" charset="-122"/>
                           <a:cs typeface="Calibri" pitchFamily="34" charset="-120"/>
                         </a:rPr>
-                        <a:t>1354 автотеста проходят (v0.3.0, evidence.json), независимая проверка на Cedar, реестр утверждений: каждое число воспроизводится командой</a:t>
+                        <a:t>1375 автотестов проходят (v0.3.0, evidence.json), независимая проверка на Cedar, реестр утверждений: каждое число воспроизводится командой</a:t>
                       </a:r>
                       <a:endParaRPr lang="en-US" sz="1300" dirty="0">
                         <a:latin typeface="Calibri" charset="0"/>

</xml_diff>

<commit_message>
chore(M-04): regenerate evidence and deck
</commit_message>
<xml_diff>
--- a/submission/slides/Mandat_VTB.pptx
+++ b/submission/slides/Mandat_VTB.pptx
@@ -134,7 +134,7 @@
   <p:extLst>
     <p:ext uri="{521415D9-36F7-43E2-AB2F-B90AF26B5E84}">
       <p14:sectionLst xmlns:p14="http://schemas.microsoft.com/office/powerpoint/2010/main">
-        <p14:section name="Питч · 5 минут" id="{0d487e5d-13d1-27a9-c751-c94e621acd17}">
+        <p14:section name="Питч · 5 минут" id="{768ba650-6f76-8537-3d3e-438fe988ae03}">
           <p14:sldIdLst>
             <p14:sldId id="256"/>
             <p14:sldId id="257"/>
@@ -152,7 +152,7 @@
             <p14:sldId id="269"/>
           </p14:sldIdLst>
         </p14:section>
-        <p14:section name="Приложение для вопросов жюри" id="{f7d1debb-f8d1-30ff-679c-814fc922e812}">
+        <p14:section name="Приложение для вопросов жюри" id="{ccee6c03-cd82-2109-11d1-244cfb921afb}">
           <p14:sldIdLst>
             <p14:sldId id="270"/>
             <p14:sldId id="271"/>
@@ -6183,7 +6183,7 @@
                   <a:schemeClr val="accent4"/>
                 </a:solidFill>
               </a:rPr>
-              <a:t>Источники: vtb.ru — «Комплект МЧД и КЭП» в «ВТБ Бизнес», 10.2026; репозиторий «Мандата» v0.3.0: 1375 автотестов, evidence.json от 16.10.2026</a:t>
+              <a:t>Источники: vtb.ru — «Комплект МЧД и КЭП» в «ВТБ Бизнес», 10.2026; репозиторий «Мандата» v0.3.0: 1394 автотеста, evidence.json от 16.10.2026</a:t>
             </a:r>
             <a:endParaRPr lang="en-US" sz="1000" dirty="0"/>
           </a:p>
@@ -7046,7 +7046,7 @@
                   <a:schemeClr val="bg1"/>
                 </a:solidFill>
               </a:rPr>
-              <a:t>1375 автотестов проходят, каждое число воспроизводится командой</a:t>
+              <a:t>1394 автотеста проходят, каждое число воспроизводится командой</a:t>
             </a:r>
             <a:endParaRPr lang="en-US" sz="1500" dirty="0"/>
           </a:p>
@@ -12430,7 +12430,7 @@
                           <a:ea typeface="Calibri" pitchFamily="34" charset="-122"/>
                           <a:cs typeface="Calibri" pitchFamily="34" charset="-120"/>
                         </a:rPr>
-                        <a:t>1375 автотестов; evidence.json</a:t>
+                        <a:t>1394 автотестов; evidence.json</a:t>
                       </a:r>
                       <a:endParaRPr lang="en-US" sz="1400" dirty="0">
                         <a:latin typeface="Calibri" charset="0"/>
@@ -25390,7 +25390,7 @@
                           <a:ea typeface="Calibri" pitchFamily="34" charset="-122"/>
                           <a:cs typeface="Calibri" pitchFamily="34" charset="-120"/>
                         </a:rPr>
-                        <a:t>1375 автотестов проходят (v0.3.0, evidence.json), независимая проверка на Cedar, реестр утверждений: каждое число воспроизводится командой</a:t>
+                        <a:t>1394 автотеста проходят (v0.3.0, evidence.json), независимая проверка на Cedar, реестр утверждений: каждое число воспроизводится командой</a:t>
                       </a:r>
                       <a:endParaRPr lang="en-US" sz="1300" dirty="0">
                         <a:latin typeface="Calibri" charset="0"/>

</xml_diff>